<commit_message>
fixed error reduction property.
</commit_message>
<xml_diff>
--- a/slides/Lecture_Chapter07.pptx
+++ b/slides/Lecture_Chapter07.pptx
@@ -22,7 +22,8 @@
     <p:sldId id="389" r:id="rId16"/>
     <p:sldId id="390" r:id="rId17"/>
     <p:sldId id="395" r:id="rId18"/>
-    <p:sldId id="397" r:id="rId19"/>
+    <p:sldId id="481" r:id="rId19"/>
+    <p:sldId id="397" r:id="rId20"/>
   </p:sldIdLst>
   <p:sldSz cx="12192000" cy="6858000"/>
   <p:notesSz cx="6858000" cy="9144000"/>
@@ -159,6 +160,7 @@
             <p14:sldId id="389"/>
             <p14:sldId id="390"/>
             <p14:sldId id="395"/>
+            <p14:sldId id="481"/>
             <p14:sldId id="397"/>
           </p14:sldIdLst>
         </p14:section>
@@ -318,7 +320,7 @@
           <a:p>
             <a:fld id="{3E22BF2E-04DA-469E-97C5-BB68A0368813}" type="datetimeFigureOut">
               <a:rPr lang="en-US" smtClean="0"/>
-              <a:t>10/5/2026</a:t>
+              <a:t>10/7/2026</a:t>
             </a:fld>
             <a:endParaRPr lang="en-US"/>
           </a:p>
@@ -516,7 +518,7 @@
           <a:p>
             <a:fld id="{3E22BF2E-04DA-469E-97C5-BB68A0368813}" type="datetimeFigureOut">
               <a:rPr lang="en-US" smtClean="0"/>
-              <a:t>10/5/2026</a:t>
+              <a:t>10/7/2026</a:t>
             </a:fld>
             <a:endParaRPr lang="en-US"/>
           </a:p>
@@ -724,7 +726,7 @@
           <a:p>
             <a:fld id="{3E22BF2E-04DA-469E-97C5-BB68A0368813}" type="datetimeFigureOut">
               <a:rPr lang="en-US" smtClean="0"/>
-              <a:t>10/5/2026</a:t>
+              <a:t>10/7/2026</a:t>
             </a:fld>
             <a:endParaRPr lang="en-US"/>
           </a:p>
@@ -932,7 +934,7 @@
           <a:p>
             <a:fld id="{3E22BF2E-04DA-469E-97C5-BB68A0368813}" type="datetimeFigureOut">
               <a:rPr lang="en-US" smtClean="0"/>
-              <a:t>10/5/2026</a:t>
+              <a:t>10/7/2026</a:t>
             </a:fld>
             <a:endParaRPr lang="en-US"/>
           </a:p>
@@ -1207,7 +1209,7 @@
           <a:p>
             <a:fld id="{3E22BF2E-04DA-469E-97C5-BB68A0368813}" type="datetimeFigureOut">
               <a:rPr lang="en-US" smtClean="0"/>
-              <a:t>10/5/2026</a:t>
+              <a:t>10/7/2026</a:t>
             </a:fld>
             <a:endParaRPr lang="en-US"/>
           </a:p>
@@ -1472,7 +1474,7 @@
           <a:p>
             <a:fld id="{3E22BF2E-04DA-469E-97C5-BB68A0368813}" type="datetimeFigureOut">
               <a:rPr lang="en-US" smtClean="0"/>
-              <a:t>10/5/2026</a:t>
+              <a:t>10/7/2026</a:t>
             </a:fld>
             <a:endParaRPr lang="en-US"/>
           </a:p>
@@ -1884,7 +1886,7 @@
           <a:p>
             <a:fld id="{3E22BF2E-04DA-469E-97C5-BB68A0368813}" type="datetimeFigureOut">
               <a:rPr lang="en-US" smtClean="0"/>
-              <a:t>10/5/2026</a:t>
+              <a:t>10/7/2026</a:t>
             </a:fld>
             <a:endParaRPr lang="en-US"/>
           </a:p>
@@ -2025,7 +2027,7 @@
           <a:p>
             <a:fld id="{3E22BF2E-04DA-469E-97C5-BB68A0368813}" type="datetimeFigureOut">
               <a:rPr lang="en-US" smtClean="0"/>
-              <a:t>10/5/2026</a:t>
+              <a:t>10/7/2026</a:t>
             </a:fld>
             <a:endParaRPr lang="en-US"/>
           </a:p>
@@ -2138,7 +2140,7 @@
           <a:p>
             <a:fld id="{3E22BF2E-04DA-469E-97C5-BB68A0368813}" type="datetimeFigureOut">
               <a:rPr lang="en-US" smtClean="0"/>
-              <a:t>10/5/2026</a:t>
+              <a:t>10/7/2026</a:t>
             </a:fld>
             <a:endParaRPr lang="en-US"/>
           </a:p>
@@ -2449,7 +2451,7 @@
           <a:p>
             <a:fld id="{3E22BF2E-04DA-469E-97C5-BB68A0368813}" type="datetimeFigureOut">
               <a:rPr lang="en-US" smtClean="0"/>
-              <a:t>10/5/2026</a:t>
+              <a:t>10/7/2026</a:t>
             </a:fld>
             <a:endParaRPr lang="en-US"/>
           </a:p>
@@ -2737,7 +2739,7 @@
           <a:p>
             <a:fld id="{3E22BF2E-04DA-469E-97C5-BB68A0368813}" type="datetimeFigureOut">
               <a:rPr lang="en-US" smtClean="0"/>
-              <a:t>10/5/2026</a:t>
+              <a:t>10/7/2026</a:t>
             </a:fld>
             <a:endParaRPr lang="en-US"/>
           </a:p>
@@ -2978,7 +2980,7 @@
           <a:p>
             <a:fld id="{3E22BF2E-04DA-469E-97C5-BB68A0368813}" type="datetimeFigureOut">
               <a:rPr lang="en-US" smtClean="0"/>
-              <a:t>10/5/2026</a:t>
+              <a:t>10/7/2026</a:t>
             </a:fld>
             <a:endParaRPr lang="en-US"/>
           </a:p>
@@ -4715,7 +4717,7 @@
                         <m:begChr m:val="["/>
                         <m:endChr m:val="]"/>
                         <m:ctrlPr>
-                          <a:rPr lang="en-US" b="0" i="1" smtClean="0">
+                          <a:rPr lang="en-US" i="1">
                             <a:latin typeface="Cambria Math" panose="02040503050406030204" pitchFamily="18" charset="0"/>
                             <a:ea typeface="Cambria Math" panose="02040503050406030204" pitchFamily="18" charset="0"/>
                           </a:rPr>
@@ -4827,7 +4829,7 @@
                         <m:begChr m:val="["/>
                         <m:endChr m:val="]"/>
                         <m:ctrlPr>
-                          <a:rPr lang="en-US" b="0" i="1" smtClean="0">
+                          <a:rPr lang="en-US" i="1">
                             <a:latin typeface="Cambria Math" panose="02040503050406030204" pitchFamily="18" charset="0"/>
                             <a:ea typeface="Cambria Math" panose="02040503050406030204" pitchFamily="18" charset="0"/>
                           </a:rPr>
@@ -4991,7 +4993,7 @@
                         <m:begChr m:val="["/>
                         <m:endChr m:val="]"/>
                         <m:ctrlPr>
-                          <a:rPr lang="en-US" b="0" i="1" smtClean="0">
+                          <a:rPr lang="en-US" i="1">
                             <a:latin typeface="Cambria Math" panose="02040503050406030204" pitchFamily="18" charset="0"/>
                             <a:ea typeface="Cambria Math" panose="02040503050406030204" pitchFamily="18" charset="0"/>
                           </a:rPr>
@@ -5173,7 +5175,7 @@
                         <m:begChr m:val="["/>
                         <m:endChr m:val="]"/>
                         <m:ctrlPr>
-                          <a:rPr lang="en-US" b="0" i="1" smtClean="0">
+                          <a:rPr lang="en-US" i="1">
                             <a:latin typeface="Cambria Math" panose="02040503050406030204" pitchFamily="18" charset="0"/>
                             <a:ea typeface="Cambria Math" panose="02040503050406030204" pitchFamily="18" charset="0"/>
                           </a:rPr>
@@ -5339,7 +5341,7 @@
                                     <m:begChr m:val="["/>
                                     <m:endChr m:val="]"/>
                                     <m:ctrlPr>
-                                      <a:rPr lang="en-US" b="0" i="1" smtClean="0">
+                                      <a:rPr lang="en-US" i="1">
                                         <a:latin typeface="Cambria Math" panose="02040503050406030204" pitchFamily="18" charset="0"/>
                                         <a:ea typeface="Cambria Math" panose="02040503050406030204" pitchFamily="18" charset="0"/>
                                       </a:rPr>
@@ -6374,7 +6376,7 @@
                     <m:sSub>
                       <m:sSubPr>
                         <m:ctrlPr>
-                          <a:rPr lang="en-US" sz="1600" i="1" smtClean="0">
+                          <a:rPr lang="en-US" sz="1600" i="1">
                             <a:latin typeface="Cambria Math" panose="02040503050406030204" pitchFamily="18" charset="0"/>
                             <a:ea typeface="Cambria Math" panose="02040503050406030204" pitchFamily="18" charset="0"/>
                           </a:rPr>
@@ -9794,7 +9796,7 @@
           <a:lstStyle/>
           <a:p>
             <a:pPr algn="ctr"/>
-            <a:endParaRPr lang="en-US"/>
+            <a:endParaRPr lang="en-US" dirty="0"/>
           </a:p>
         </p:txBody>
       </p:sp>
@@ -12489,6 +12491,873 @@
 <file path=ppt/slides/slide18.xml><?xml version="1.0" encoding="utf-8"?>
 <p:sld xmlns:a="http://schemas.openxmlformats.org/drawingml/2006/main" xmlns:r="http://schemas.openxmlformats.org/officeDocument/2006/relationships" xmlns:p="http://schemas.openxmlformats.org/presentationml/2006/main">
   <p:cSld>
+    <p:spTree>
+      <p:nvGrpSpPr>
+        <p:cNvPr id="1" name=""/>
+        <p:cNvGrpSpPr/>
+        <p:nvPr/>
+      </p:nvGrpSpPr>
+      <p:grpSpPr>
+        <a:xfrm>
+          <a:off x="0" y="0"/>
+          <a:ext cx="0" cy="0"/>
+          <a:chOff x="0" y="0"/>
+          <a:chExt cx="0" cy="0"/>
+        </a:xfrm>
+      </p:grpSpPr>
+      <mc:AlternateContent xmlns:mc="http://schemas.openxmlformats.org/markup-compatibility/2006" xmlns:a14="http://schemas.microsoft.com/office/drawing/2010/main">
+        <mc:Choice Requires="a14">
+          <p:sp>
+            <p:nvSpPr>
+              <p:cNvPr id="2" name="Title 1">
+                <a:extLst>
+                  <a:ext uri="{FF2B5EF4-FFF2-40B4-BE49-F238E27FC236}">
+                    <a16:creationId xmlns:a16="http://schemas.microsoft.com/office/drawing/2014/main" id="{FDA87B64-32A5-338D-6776-2AC3654F00AC}"/>
+                  </a:ext>
+                </a:extLst>
+              </p:cNvPr>
+              <p:cNvSpPr>
+                <a:spLocks noGrp="1"/>
+              </p:cNvSpPr>
+              <p:nvPr>
+                <p:ph type="title"/>
+              </p:nvPr>
+            </p:nvSpPr>
+            <p:spPr/>
+            <p:txBody>
+              <a:bodyPr/>
+              <a:lstStyle/>
+              <a:p>
+                <a14:m>
+                  <m:oMath xmlns:m="http://schemas.openxmlformats.org/officeDocument/2006/math">
+                    <m:r>
+                      <a:rPr lang="en-US" b="0" i="1" dirty="0" smtClean="0">
+                        <a:latin typeface="Cambria Math" panose="02040503050406030204" pitchFamily="18" charset="0"/>
+                      </a:rPr>
+                      <m:t>𝑛</m:t>
+                    </m:r>
+                  </m:oMath>
+                </a14:m>
+                <a:r>
+                  <a:rPr lang="en-US" dirty="0"/>
+                  <a:t>-Step Q-Learning</a:t>
+                </a:r>
+              </a:p>
+            </p:txBody>
+          </p:sp>
+        </mc:Choice>
+        <mc:Fallback xmlns="">
+          <p:sp>
+            <p:nvSpPr>
+              <p:cNvPr id="2" name="Title 1">
+                <a:extLst>
+                  <a:ext uri="{FF2B5EF4-FFF2-40B4-BE49-F238E27FC236}">
+                    <a16:creationId xmlns:a16="http://schemas.microsoft.com/office/drawing/2014/main" id="{FDA87B64-32A5-338D-6776-2AC3654F00AC}"/>
+                  </a:ext>
+                </a:extLst>
+              </p:cNvPr>
+              <p:cNvSpPr>
+                <a:spLocks noGrp="1" noRot="1" noChangeAspect="1" noMove="1" noResize="1" noEditPoints="1" noAdjustHandles="1" noChangeArrowheads="1" noChangeShapeType="1" noTextEdit="1"/>
+              </p:cNvSpPr>
+              <p:nvPr>
+                <p:ph type="title"/>
+              </p:nvPr>
+            </p:nvSpPr>
+            <p:spPr>
+              <a:blipFill>
+                <a:blip r:embed="rId2"/>
+                <a:stretch>
+                  <a:fillRect t="-20161" b="-35484"/>
+                </a:stretch>
+              </a:blipFill>
+            </p:spPr>
+            <p:txBody>
+              <a:bodyPr/>
+              <a:lstStyle/>
+              <a:p>
+                <a:r>
+                  <a:rPr lang="en-US">
+                    <a:noFill/>
+                  </a:rPr>
+                  <a:t> </a:t>
+                </a:r>
+              </a:p>
+            </p:txBody>
+          </p:sp>
+        </mc:Fallback>
+      </mc:AlternateContent>
+      <mc:AlternateContent xmlns:mc="http://schemas.openxmlformats.org/markup-compatibility/2006" xmlns:a14="http://schemas.microsoft.com/office/drawing/2010/main">
+        <mc:Choice Requires="a14">
+          <p:sp>
+            <p:nvSpPr>
+              <p:cNvPr id="3" name="Content Placeholder 2">
+                <a:extLst>
+                  <a:ext uri="{FF2B5EF4-FFF2-40B4-BE49-F238E27FC236}">
+                    <a16:creationId xmlns:a16="http://schemas.microsoft.com/office/drawing/2014/main" id="{89A5D9A4-5700-5EBA-0E79-41C2AA003632}"/>
+                  </a:ext>
+                </a:extLst>
+              </p:cNvPr>
+              <p:cNvSpPr>
+                <a:spLocks noGrp="1"/>
+              </p:cNvSpPr>
+              <p:nvPr>
+                <p:ph idx="1"/>
+              </p:nvPr>
+            </p:nvSpPr>
+            <p:spPr/>
+            <p:txBody>
+              <a:bodyPr>
+                <a:normAutofit lnSpcReduction="10000"/>
+              </a:bodyPr>
+              <a:lstStyle/>
+              <a:p>
+                <a:pPr marL="0" indent="0">
+                  <a:buNone/>
+                </a:pPr>
+                <a14:m>
+                  <m:oMath xmlns:m="http://schemas.openxmlformats.org/officeDocument/2006/math">
+                    <m:r>
+                      <a:rPr lang="en-US" i="1" dirty="0">
+                        <a:latin typeface="Cambria Math" panose="02040503050406030204" pitchFamily="18" charset="0"/>
+                      </a:rPr>
+                      <m:t>𝑛</m:t>
+                    </m:r>
+                  </m:oMath>
+                </a14:m>
+                <a:r>
+                  <a:rPr lang="en-US" dirty="0"/>
+                  <a:t>-step return estimate used as the target:</a:t>
+                </a:r>
+              </a:p>
+              <a:p>
+                <a:pPr marL="0" indent="0">
+                  <a:buNone/>
+                </a:pPr>
+                <a:endParaRPr lang="en-US" dirty="0"/>
+              </a:p>
+              <a:p>
+                <a:pPr marL="0" indent="0">
+                  <a:buNone/>
+                </a:pPr>
+                <a14:m>
+                  <m:oMathPara xmlns:m="http://schemas.openxmlformats.org/officeDocument/2006/math">
+                    <m:oMath>
+                      <m:sSub>
+                        <m:sSubPr>
+                          <m:ctrlPr>
+                            <a:rPr lang="en-US" i="1">
+                              <a:latin typeface="Cambria Math" panose="02040503050406030204" pitchFamily="18" charset="0"/>
+                            </a:rPr>
+                          </m:ctrlPr>
+                        </m:sSubPr>
+                        <m:e>
+                          <m:r>
+                            <a:rPr lang="en-US" i="1">
+                              <a:latin typeface="Cambria Math" panose="02040503050406030204" pitchFamily="18" charset="0"/>
+                            </a:rPr>
+                            <m:t>𝐺</m:t>
+                          </m:r>
+                        </m:e>
+                        <m:sub>
+                          <m:r>
+                            <a:rPr lang="en-US" i="1">
+                              <a:latin typeface="Cambria Math" panose="02040503050406030204" pitchFamily="18" charset="0"/>
+                            </a:rPr>
+                            <m:t>𝑡</m:t>
+                          </m:r>
+                          <m:r>
+                            <a:rPr lang="en-US" i="1">
+                              <a:latin typeface="Cambria Math" panose="02040503050406030204" pitchFamily="18" charset="0"/>
+                            </a:rPr>
+                            <m:t>:</m:t>
+                          </m:r>
+                          <m:r>
+                            <a:rPr lang="en-US" i="1">
+                              <a:latin typeface="Cambria Math" panose="02040503050406030204" pitchFamily="18" charset="0"/>
+                            </a:rPr>
+                            <m:t>𝑡</m:t>
+                          </m:r>
+                          <m:r>
+                            <a:rPr lang="en-US" i="1">
+                              <a:latin typeface="Cambria Math" panose="02040503050406030204" pitchFamily="18" charset="0"/>
+                            </a:rPr>
+                            <m:t>+</m:t>
+                          </m:r>
+                          <m:r>
+                            <a:rPr lang="en-US" i="1">
+                              <a:latin typeface="Cambria Math" panose="02040503050406030204" pitchFamily="18" charset="0"/>
+                            </a:rPr>
+                            <m:t>𝑛</m:t>
+                          </m:r>
+                        </m:sub>
+                      </m:sSub>
+                      <m:r>
+                        <a:rPr lang="en-US" i="1">
+                          <a:latin typeface="Cambria Math" panose="02040503050406030204" pitchFamily="18" charset="0"/>
+                        </a:rPr>
+                        <m:t>=</m:t>
+                      </m:r>
+                      <m:sSub>
+                        <m:sSubPr>
+                          <m:ctrlPr>
+                            <a:rPr lang="en-US" i="1">
+                              <a:latin typeface="Cambria Math" panose="02040503050406030204" pitchFamily="18" charset="0"/>
+                            </a:rPr>
+                          </m:ctrlPr>
+                        </m:sSubPr>
+                        <m:e>
+                          <m:r>
+                            <a:rPr lang="en-US" i="1">
+                              <a:latin typeface="Cambria Math" panose="02040503050406030204" pitchFamily="18" charset="0"/>
+                            </a:rPr>
+                            <m:t>𝑅</m:t>
+                          </m:r>
+                        </m:e>
+                        <m:sub>
+                          <m:r>
+                            <a:rPr lang="en-US" i="1">
+                              <a:latin typeface="Cambria Math" panose="02040503050406030204" pitchFamily="18" charset="0"/>
+                            </a:rPr>
+                            <m:t>𝑡</m:t>
+                          </m:r>
+                          <m:r>
+                            <a:rPr lang="en-US" i="1">
+                              <a:latin typeface="Cambria Math" panose="02040503050406030204" pitchFamily="18" charset="0"/>
+                            </a:rPr>
+                            <m:t>+1</m:t>
+                          </m:r>
+                        </m:sub>
+                      </m:sSub>
+                      <m:r>
+                        <a:rPr lang="en-US" i="1">
+                          <a:latin typeface="Cambria Math" panose="02040503050406030204" pitchFamily="18" charset="0"/>
+                        </a:rPr>
+                        <m:t>+</m:t>
+                      </m:r>
+                      <m:r>
+                        <a:rPr lang="en-US" i="1">
+                          <a:latin typeface="Cambria Math" panose="02040503050406030204" pitchFamily="18" charset="0"/>
+                        </a:rPr>
+                        <m:t>𝛾</m:t>
+                      </m:r>
+                      <m:sSub>
+                        <m:sSubPr>
+                          <m:ctrlPr>
+                            <a:rPr lang="en-US" i="1">
+                              <a:latin typeface="Cambria Math" panose="02040503050406030204" pitchFamily="18" charset="0"/>
+                            </a:rPr>
+                          </m:ctrlPr>
+                        </m:sSubPr>
+                        <m:e>
+                          <m:r>
+                            <a:rPr lang="en-US" i="1">
+                              <a:latin typeface="Cambria Math" panose="02040503050406030204" pitchFamily="18" charset="0"/>
+                            </a:rPr>
+                            <m:t>𝑅</m:t>
+                          </m:r>
+                        </m:e>
+                        <m:sub>
+                          <m:r>
+                            <a:rPr lang="en-US" i="1">
+                              <a:latin typeface="Cambria Math" panose="02040503050406030204" pitchFamily="18" charset="0"/>
+                            </a:rPr>
+                            <m:t>𝑡</m:t>
+                          </m:r>
+                          <m:r>
+                            <a:rPr lang="en-US" i="1">
+                              <a:latin typeface="Cambria Math" panose="02040503050406030204" pitchFamily="18" charset="0"/>
+                            </a:rPr>
+                            <m:t>+2</m:t>
+                          </m:r>
+                        </m:sub>
+                      </m:sSub>
+                      <m:r>
+                        <a:rPr lang="en-US" i="1">
+                          <a:latin typeface="Cambria Math" panose="02040503050406030204" pitchFamily="18" charset="0"/>
+                        </a:rPr>
+                        <m:t>+…+</m:t>
+                      </m:r>
+                      <m:sSup>
+                        <m:sSupPr>
+                          <m:ctrlPr>
+                            <a:rPr lang="en-US" i="1">
+                              <a:latin typeface="Cambria Math" panose="02040503050406030204" pitchFamily="18" charset="0"/>
+                            </a:rPr>
+                          </m:ctrlPr>
+                        </m:sSupPr>
+                        <m:e>
+                          <m:r>
+                            <a:rPr lang="en-US" i="1">
+                              <a:latin typeface="Cambria Math" panose="02040503050406030204" pitchFamily="18" charset="0"/>
+                            </a:rPr>
+                            <m:t>𝛾</m:t>
+                          </m:r>
+                        </m:e>
+                        <m:sup>
+                          <m:r>
+                            <a:rPr lang="en-US" i="1">
+                              <a:latin typeface="Cambria Math" panose="02040503050406030204" pitchFamily="18" charset="0"/>
+                            </a:rPr>
+                            <m:t>𝑛</m:t>
+                          </m:r>
+                          <m:r>
+                            <a:rPr lang="en-US" i="1">
+                              <a:latin typeface="Cambria Math" panose="02040503050406030204" pitchFamily="18" charset="0"/>
+                            </a:rPr>
+                            <m:t>−1</m:t>
+                          </m:r>
+                        </m:sup>
+                      </m:sSup>
+                      <m:sSub>
+                        <m:sSubPr>
+                          <m:ctrlPr>
+                            <a:rPr lang="en-US" i="1">
+                              <a:latin typeface="Cambria Math" panose="02040503050406030204" pitchFamily="18" charset="0"/>
+                            </a:rPr>
+                          </m:ctrlPr>
+                        </m:sSubPr>
+                        <m:e>
+                          <m:r>
+                            <a:rPr lang="en-US" i="1">
+                              <a:latin typeface="Cambria Math" panose="02040503050406030204" pitchFamily="18" charset="0"/>
+                            </a:rPr>
+                            <m:t>𝑅</m:t>
+                          </m:r>
+                        </m:e>
+                        <m:sub>
+                          <m:r>
+                            <a:rPr lang="en-US" i="1">
+                              <a:latin typeface="Cambria Math" panose="02040503050406030204" pitchFamily="18" charset="0"/>
+                            </a:rPr>
+                            <m:t>𝑡</m:t>
+                          </m:r>
+                          <m:r>
+                            <a:rPr lang="en-US" i="1">
+                              <a:latin typeface="Cambria Math" panose="02040503050406030204" pitchFamily="18" charset="0"/>
+                            </a:rPr>
+                            <m:t>+</m:t>
+                          </m:r>
+                          <m:r>
+                            <a:rPr lang="en-US" i="1">
+                              <a:latin typeface="Cambria Math" panose="02040503050406030204" pitchFamily="18" charset="0"/>
+                            </a:rPr>
+                            <m:t>𝑛</m:t>
+                          </m:r>
+                        </m:sub>
+                      </m:sSub>
+                      <m:r>
+                        <a:rPr lang="en-US" i="1">
+                          <a:latin typeface="Cambria Math" panose="02040503050406030204" pitchFamily="18" charset="0"/>
+                        </a:rPr>
+                        <m:t>+</m:t>
+                      </m:r>
+                      <m:sSup>
+                        <m:sSupPr>
+                          <m:ctrlPr>
+                            <a:rPr lang="en-US" i="1">
+                              <a:latin typeface="Cambria Math" panose="02040503050406030204" pitchFamily="18" charset="0"/>
+                            </a:rPr>
+                          </m:ctrlPr>
+                        </m:sSupPr>
+                        <m:e>
+                          <m:r>
+                            <a:rPr lang="en-US" i="1">
+                              <a:latin typeface="Cambria Math" panose="02040503050406030204" pitchFamily="18" charset="0"/>
+                            </a:rPr>
+                            <m:t>𝛾</m:t>
+                          </m:r>
+                        </m:e>
+                        <m:sup>
+                          <m:r>
+                            <a:rPr lang="en-US" i="1">
+                              <a:latin typeface="Cambria Math" panose="02040503050406030204" pitchFamily="18" charset="0"/>
+                            </a:rPr>
+                            <m:t>𝑛</m:t>
+                          </m:r>
+                        </m:sup>
+                      </m:sSup>
+                      <m:r>
+                        <a:rPr lang="en-US" i="1">
+                          <a:latin typeface="Cambria Math" panose="02040503050406030204" pitchFamily="18" charset="0"/>
+                        </a:rPr>
+                        <m:t>𝑄</m:t>
+                      </m:r>
+                      <m:d>
+                        <m:dPr>
+                          <m:ctrlPr>
+                            <a:rPr lang="en-US" i="1">
+                              <a:latin typeface="Cambria Math" panose="02040503050406030204" pitchFamily="18" charset="0"/>
+                            </a:rPr>
+                          </m:ctrlPr>
+                        </m:dPr>
+                        <m:e>
+                          <m:sSub>
+                            <m:sSubPr>
+                              <m:ctrlPr>
+                                <a:rPr lang="en-US" i="1">
+                                  <a:latin typeface="Cambria Math" panose="02040503050406030204" pitchFamily="18" charset="0"/>
+                                </a:rPr>
+                              </m:ctrlPr>
+                            </m:sSubPr>
+                            <m:e>
+                              <m:r>
+                                <a:rPr lang="en-US" i="1">
+                                  <a:latin typeface="Cambria Math" panose="02040503050406030204" pitchFamily="18" charset="0"/>
+                                </a:rPr>
+                                <m:t>𝑆</m:t>
+                              </m:r>
+                            </m:e>
+                            <m:sub>
+                              <m:r>
+                                <a:rPr lang="en-US" i="1">
+                                  <a:latin typeface="Cambria Math" panose="02040503050406030204" pitchFamily="18" charset="0"/>
+                                </a:rPr>
+                                <m:t>𝑡</m:t>
+                              </m:r>
+                              <m:r>
+                                <a:rPr lang="en-US" i="1">
+                                  <a:latin typeface="Cambria Math" panose="02040503050406030204" pitchFamily="18" charset="0"/>
+                                </a:rPr>
+                                <m:t>+</m:t>
+                              </m:r>
+                              <m:r>
+                                <a:rPr lang="en-US" i="1">
+                                  <a:latin typeface="Cambria Math" panose="02040503050406030204" pitchFamily="18" charset="0"/>
+                                </a:rPr>
+                                <m:t>𝑛</m:t>
+                              </m:r>
+                            </m:sub>
+                          </m:sSub>
+                          <m:r>
+                            <a:rPr lang="en-US" i="1">
+                              <a:latin typeface="Cambria Math" panose="02040503050406030204" pitchFamily="18" charset="0"/>
+                            </a:rPr>
+                            <m:t>,</m:t>
+                          </m:r>
+                          <m:sSub>
+                            <m:sSubPr>
+                              <m:ctrlPr>
+                                <a:rPr lang="en-US" i="1">
+                                  <a:latin typeface="Cambria Math" panose="02040503050406030204" pitchFamily="18" charset="0"/>
+                                </a:rPr>
+                              </m:ctrlPr>
+                            </m:sSubPr>
+                            <m:e>
+                              <m:r>
+                                <a:rPr lang="en-US" i="1">
+                                  <a:latin typeface="Cambria Math" panose="02040503050406030204" pitchFamily="18" charset="0"/>
+                                </a:rPr>
+                                <m:t>𝐴</m:t>
+                              </m:r>
+                            </m:e>
+                            <m:sub>
+                              <m:r>
+                                <a:rPr lang="en-US" i="1">
+                                  <a:latin typeface="Cambria Math" panose="02040503050406030204" pitchFamily="18" charset="0"/>
+                                </a:rPr>
+                                <m:t>𝑡</m:t>
+                              </m:r>
+                              <m:r>
+                                <a:rPr lang="en-US" i="1">
+                                  <a:latin typeface="Cambria Math" panose="02040503050406030204" pitchFamily="18" charset="0"/>
+                                </a:rPr>
+                                <m:t>+</m:t>
+                              </m:r>
+                              <m:r>
+                                <a:rPr lang="en-US" i="1">
+                                  <a:latin typeface="Cambria Math" panose="02040503050406030204" pitchFamily="18" charset="0"/>
+                                </a:rPr>
+                                <m:t>𝑛</m:t>
+                              </m:r>
+                            </m:sub>
+                          </m:sSub>
+                        </m:e>
+                      </m:d>
+                    </m:oMath>
+                  </m:oMathPara>
+                </a14:m>
+                <a:endParaRPr lang="en-US" dirty="0"/>
+              </a:p>
+              <a:p>
+                <a:endParaRPr lang="en-US" dirty="0"/>
+              </a:p>
+              <a:p>
+                <a:endParaRPr lang="en-US" dirty="0"/>
+              </a:p>
+              <a:p>
+                <a:pPr marL="0" indent="0">
+                  <a:buNone/>
+                </a:pPr>
+                <a:endParaRPr lang="en-US" dirty="0"/>
+              </a:p>
+              <a:p>
+                <a:r>
+                  <a:rPr lang="en-US" dirty="0"/>
+                  <a:t>Q-Learning needs a return estimate for the target policy. Mixing rewards form the behavior policy with a bootstrapped Q-value from the target policy is an issue!</a:t>
+                </a:r>
+              </a:p>
+              <a:p>
+                <a:r>
+                  <a:rPr lang="en-US" dirty="0"/>
+                  <a:t>We would still need importance sampling to fix the rewards.</a:t>
+                </a:r>
+              </a:p>
+              <a:p>
+                <a:r>
+                  <a:rPr lang="en-US" dirty="0"/>
+                  <a:t>Most applications stick with </a:t>
+                </a:r>
+                <a14:m>
+                  <m:oMath xmlns:m="http://schemas.openxmlformats.org/officeDocument/2006/math">
+                    <m:r>
+                      <a:rPr lang="en-US" i="1" dirty="0" smtClean="0">
+                        <a:latin typeface="Cambria Math" panose="02040503050406030204" pitchFamily="18" charset="0"/>
+                      </a:rPr>
+                      <m:t>𝑛</m:t>
+                    </m:r>
+                  </m:oMath>
+                </a14:m>
+                <a:r>
+                  <a:rPr lang="en-US" dirty="0"/>
+                  <a:t>-step Sarsa.</a:t>
+                </a:r>
+              </a:p>
+              <a:p>
+                <a:pPr marL="0" indent="0">
+                  <a:buNone/>
+                </a:pPr>
+                <a:endParaRPr lang="en-US" dirty="0"/>
+              </a:p>
+            </p:txBody>
+          </p:sp>
+        </mc:Choice>
+        <mc:Fallback xmlns="">
+          <p:sp>
+            <p:nvSpPr>
+              <p:cNvPr id="3" name="Content Placeholder 2">
+                <a:extLst>
+                  <a:ext uri="{FF2B5EF4-FFF2-40B4-BE49-F238E27FC236}">
+                    <a16:creationId xmlns:a16="http://schemas.microsoft.com/office/drawing/2014/main" id="{89A5D9A4-5700-5EBA-0E79-41C2AA003632}"/>
+                  </a:ext>
+                </a:extLst>
+              </p:cNvPr>
+              <p:cNvSpPr>
+                <a:spLocks noGrp="1" noRot="1" noChangeAspect="1" noMove="1" noResize="1" noEditPoints="1" noAdjustHandles="1" noChangeArrowheads="1" noChangeShapeType="1" noTextEdit="1"/>
+              </p:cNvSpPr>
+              <p:nvPr>
+                <p:ph idx="1"/>
+              </p:nvPr>
+            </p:nvSpPr>
+            <p:spPr>
+              <a:blipFill>
+                <a:blip r:embed="rId3"/>
+                <a:stretch>
+                  <a:fillRect l="-1043" t="-2806" b="-3827"/>
+                </a:stretch>
+              </a:blipFill>
+            </p:spPr>
+            <p:txBody>
+              <a:bodyPr/>
+              <a:lstStyle/>
+              <a:p>
+                <a:r>
+                  <a:rPr lang="en-US">
+                    <a:noFill/>
+                  </a:rPr>
+                  <a:t> </a:t>
+                </a:r>
+              </a:p>
+            </p:txBody>
+          </p:sp>
+        </mc:Fallback>
+      </mc:AlternateContent>
+      <mc:AlternateContent xmlns:mc="http://schemas.openxmlformats.org/markup-compatibility/2006" xmlns:a14="http://schemas.microsoft.com/office/drawing/2010/main">
+        <mc:Choice Requires="a14">
+          <p:sp>
+            <p:nvSpPr>
+              <p:cNvPr id="4" name="Speech Bubble: Rectangle with Corners Rounded 3">
+                <a:extLst>
+                  <a:ext uri="{FF2B5EF4-FFF2-40B4-BE49-F238E27FC236}">
+                    <a16:creationId xmlns:a16="http://schemas.microsoft.com/office/drawing/2014/main" id="{0D4CA94F-E4A3-E0CE-BA8F-9A0C9D18CFA5}"/>
+                  </a:ext>
+                </a:extLst>
+              </p:cNvPr>
+              <p:cNvSpPr/>
+              <p:nvPr/>
+            </p:nvSpPr>
+            <p:spPr>
+              <a:xfrm>
+                <a:off x="8829413" y="3120221"/>
+                <a:ext cx="2797728" cy="666925"/>
+              </a:xfrm>
+              <a:prstGeom prst="wedgeRoundRectCallout">
+                <a:avLst>
+                  <a:gd name="adj1" fmla="val -8920"/>
+                  <a:gd name="adj2" fmla="val -111835"/>
+                  <a:gd name="adj3" fmla="val 16667"/>
+                </a:avLst>
+              </a:prstGeom>
+            </p:spPr>
+            <p:style>
+              <a:lnRef idx="2">
+                <a:schemeClr val="accent1">
+                  <a:shade val="15000"/>
+                </a:schemeClr>
+              </a:lnRef>
+              <a:fillRef idx="1">
+                <a:schemeClr val="accent1"/>
+              </a:fillRef>
+              <a:effectRef idx="0">
+                <a:schemeClr val="accent1"/>
+              </a:effectRef>
+              <a:fontRef idx="minor">
+                <a:schemeClr val="lt1"/>
+              </a:fontRef>
+            </p:style>
+            <p:txBody>
+              <a:bodyPr rtlCol="0" anchor="ctr"/>
+              <a:lstStyle/>
+              <a:p>
+                <a:pPr algn="ctr"/>
+                <a:r>
+                  <a:rPr lang="en-US" dirty="0"/>
+                  <a:t>Choose this action using the target policy </a:t>
+                </a:r>
+                <a14:m>
+                  <m:oMath xmlns:m="http://schemas.openxmlformats.org/officeDocument/2006/math">
+                    <m:r>
+                      <a:rPr lang="en-US" b="0" i="1" smtClean="0">
+                        <a:latin typeface="Cambria Math" panose="02040503050406030204" pitchFamily="18" charset="0"/>
+                      </a:rPr>
+                      <m:t>𝜋</m:t>
+                    </m:r>
+                  </m:oMath>
+                </a14:m>
+                <a:endParaRPr lang="en-US" dirty="0"/>
+              </a:p>
+            </p:txBody>
+          </p:sp>
+        </mc:Choice>
+        <mc:Fallback xmlns="">
+          <p:sp>
+            <p:nvSpPr>
+              <p:cNvPr id="4" name="Speech Bubble: Rectangle with Corners Rounded 3">
+                <a:extLst>
+                  <a:ext uri="{FF2B5EF4-FFF2-40B4-BE49-F238E27FC236}">
+                    <a16:creationId xmlns:a16="http://schemas.microsoft.com/office/drawing/2014/main" id="{0D4CA94F-E4A3-E0CE-BA8F-9A0C9D18CFA5}"/>
+                  </a:ext>
+                </a:extLst>
+              </p:cNvPr>
+              <p:cNvSpPr>
+                <a:spLocks noRot="1" noChangeAspect="1" noMove="1" noResize="1" noEditPoints="1" noAdjustHandles="1" noChangeArrowheads="1" noChangeShapeType="1" noTextEdit="1"/>
+              </p:cNvSpPr>
+              <p:nvPr/>
+            </p:nvSpPr>
+            <p:spPr>
+              <a:xfrm>
+                <a:off x="8829413" y="3120221"/>
+                <a:ext cx="2797728" cy="666925"/>
+              </a:xfrm>
+              <a:prstGeom prst="wedgeRoundRectCallout">
+                <a:avLst>
+                  <a:gd name="adj1" fmla="val -8920"/>
+                  <a:gd name="adj2" fmla="val -111835"/>
+                  <a:gd name="adj3" fmla="val 16667"/>
+                </a:avLst>
+              </a:prstGeom>
+              <a:blipFill>
+                <a:blip r:embed="rId4"/>
+                <a:stretch>
+                  <a:fillRect b="-7182"/>
+                </a:stretch>
+              </a:blipFill>
+            </p:spPr>
+            <p:txBody>
+              <a:bodyPr/>
+              <a:lstStyle/>
+              <a:p>
+                <a:r>
+                  <a:rPr lang="en-US">
+                    <a:noFill/>
+                  </a:rPr>
+                  <a:t> </a:t>
+                </a:r>
+              </a:p>
+            </p:txBody>
+          </p:sp>
+        </mc:Fallback>
+      </mc:AlternateContent>
+      <p:cxnSp>
+        <p:nvCxnSpPr>
+          <p:cNvPr id="6" name="Straight Connector 5">
+            <a:extLst>
+              <a:ext uri="{FF2B5EF4-FFF2-40B4-BE49-F238E27FC236}">
+                <a16:creationId xmlns:a16="http://schemas.microsoft.com/office/drawing/2014/main" id="{4E9E15BC-F019-9127-131F-E9E17173C224}"/>
+              </a:ext>
+            </a:extLst>
+          </p:cNvPr>
+          <p:cNvCxnSpPr/>
+          <p:nvPr/>
+        </p:nvCxnSpPr>
+        <p:spPr>
+          <a:xfrm>
+            <a:off x="4102217" y="2701255"/>
+            <a:ext cx="3754073" cy="0"/>
+          </a:xfrm>
+          <a:prstGeom prst="line">
+            <a:avLst/>
+          </a:prstGeom>
+        </p:spPr>
+        <p:style>
+          <a:lnRef idx="2">
+            <a:schemeClr val="accent2"/>
+          </a:lnRef>
+          <a:fillRef idx="0">
+            <a:schemeClr val="accent2"/>
+          </a:fillRef>
+          <a:effectRef idx="1">
+            <a:schemeClr val="accent2"/>
+          </a:effectRef>
+          <a:fontRef idx="minor">
+            <a:schemeClr val="tx1"/>
+          </a:fontRef>
+        </p:style>
+      </p:cxnSp>
+      <mc:AlternateContent xmlns:mc="http://schemas.openxmlformats.org/markup-compatibility/2006" xmlns:a14="http://schemas.microsoft.com/office/drawing/2010/main">
+        <mc:Choice Requires="a14">
+          <p:sp>
+            <p:nvSpPr>
+              <p:cNvPr id="8" name="Speech Bubble: Rectangle with Corners Rounded 7">
+                <a:extLst>
+                  <a:ext uri="{FF2B5EF4-FFF2-40B4-BE49-F238E27FC236}">
+                    <a16:creationId xmlns:a16="http://schemas.microsoft.com/office/drawing/2014/main" id="{CCDB4F50-B100-9216-5C41-BCC29A59BE3B}"/>
+                  </a:ext>
+                </a:extLst>
+              </p:cNvPr>
+              <p:cNvSpPr/>
+              <p:nvPr/>
+            </p:nvSpPr>
+            <p:spPr>
+              <a:xfrm>
+                <a:off x="3956807" y="3226481"/>
+                <a:ext cx="3094140" cy="666925"/>
+              </a:xfrm>
+              <a:prstGeom prst="wedgeRoundRectCallout">
+                <a:avLst>
+                  <a:gd name="adj1" fmla="val -8920"/>
+                  <a:gd name="adj2" fmla="val -111835"/>
+                  <a:gd name="adj3" fmla="val 16667"/>
+                </a:avLst>
+              </a:prstGeom>
+            </p:spPr>
+            <p:style>
+              <a:lnRef idx="2">
+                <a:schemeClr val="accent2">
+                  <a:shade val="15000"/>
+                </a:schemeClr>
+              </a:lnRef>
+              <a:fillRef idx="1">
+                <a:schemeClr val="accent2"/>
+              </a:fillRef>
+              <a:effectRef idx="0">
+                <a:schemeClr val="accent2"/>
+              </a:effectRef>
+              <a:fontRef idx="minor">
+                <a:schemeClr val="lt1"/>
+              </a:fontRef>
+            </p:style>
+            <p:txBody>
+              <a:bodyPr rtlCol="0" anchor="ctr"/>
+              <a:lstStyle/>
+              <a:p>
+                <a:pPr algn="ctr"/>
+                <a:r>
+                  <a:rPr lang="en-US" dirty="0"/>
+                  <a:t>These were sampled using the behavioral policy </a:t>
+                </a:r>
+                <a14:m>
+                  <m:oMath xmlns:m="http://schemas.openxmlformats.org/officeDocument/2006/math">
+                    <m:r>
+                      <m:rPr>
+                        <m:sty m:val="p"/>
+                      </m:rPr>
+                      <a:rPr lang="en-US" b="0" i="0" smtClean="0">
+                        <a:latin typeface="Cambria Math" panose="02040503050406030204" pitchFamily="18" charset="0"/>
+                      </a:rPr>
+                      <m:t>b</m:t>
+                    </m:r>
+                  </m:oMath>
+                </a14:m>
+                <a:endParaRPr lang="en-US" dirty="0"/>
+              </a:p>
+            </p:txBody>
+          </p:sp>
+        </mc:Choice>
+        <mc:Fallback xmlns="">
+          <p:sp>
+            <p:nvSpPr>
+              <p:cNvPr id="8" name="Speech Bubble: Rectangle with Corners Rounded 7">
+                <a:extLst>
+                  <a:ext uri="{FF2B5EF4-FFF2-40B4-BE49-F238E27FC236}">
+                    <a16:creationId xmlns:a16="http://schemas.microsoft.com/office/drawing/2014/main" id="{CCDB4F50-B100-9216-5C41-BCC29A59BE3B}"/>
+                  </a:ext>
+                </a:extLst>
+              </p:cNvPr>
+              <p:cNvSpPr>
+                <a:spLocks noRot="1" noChangeAspect="1" noMove="1" noResize="1" noEditPoints="1" noAdjustHandles="1" noChangeArrowheads="1" noChangeShapeType="1" noTextEdit="1"/>
+              </p:cNvSpPr>
+              <p:nvPr/>
+            </p:nvSpPr>
+            <p:spPr>
+              <a:xfrm>
+                <a:off x="3956807" y="3226481"/>
+                <a:ext cx="3094140" cy="666925"/>
+              </a:xfrm>
+              <a:prstGeom prst="wedgeRoundRectCallout">
+                <a:avLst>
+                  <a:gd name="adj1" fmla="val -8920"/>
+                  <a:gd name="adj2" fmla="val -111835"/>
+                  <a:gd name="adj3" fmla="val 16667"/>
+                </a:avLst>
+              </a:prstGeom>
+              <a:blipFill>
+                <a:blip r:embed="rId5"/>
+                <a:stretch>
+                  <a:fillRect b="-6593"/>
+                </a:stretch>
+              </a:blipFill>
+            </p:spPr>
+            <p:txBody>
+              <a:bodyPr/>
+              <a:lstStyle/>
+              <a:p>
+                <a:r>
+                  <a:rPr lang="en-US">
+                    <a:noFill/>
+                  </a:rPr>
+                  <a:t> </a:t>
+                </a:r>
+              </a:p>
+            </p:txBody>
+          </p:sp>
+        </mc:Fallback>
+      </mc:AlternateContent>
+    </p:spTree>
+    <p:extLst>
+      <p:ext uri="{BB962C8B-B14F-4D97-AF65-F5344CB8AC3E}">
+        <p14:creationId xmlns:p14="http://schemas.microsoft.com/office/powerpoint/2010/main" val="563198691"/>
+      </p:ext>
+    </p:extLst>
+  </p:cSld>
+  <p:clrMapOvr>
+    <a:masterClrMapping/>
+  </p:clrMapOvr>
+</p:sld>
+</file>
+
+<file path=ppt/slides/slide19.xml><?xml version="1.0" encoding="utf-8"?>
+<p:sld xmlns:a="http://schemas.openxmlformats.org/drawingml/2006/main" xmlns:r="http://schemas.openxmlformats.org/officeDocument/2006/relationships" xmlns:p="http://schemas.openxmlformats.org/presentationml/2006/main">
+  <p:cSld>
     <p:bg>
       <p:bgPr>
         <a:solidFill>
@@ -12645,7 +13514,7 @@
         </p:blipFill>
         <p:spPr bwMode="auto">
           <a:xfrm>
-            <a:off x="-1" y="10"/>
+            <a:off x="-56272" y="-3"/>
             <a:ext cx="6096001" cy="4114790"/>
           </a:xfrm>
           <a:prstGeom prst="rect">
@@ -12663,8 +13532,8 @@
           </a:extLst>
         </p:spPr>
       </p:pic>
-      <mc:AlternateContent xmlns:mc="http://schemas.openxmlformats.org/markup-compatibility/2006" xmlns:a14="http://schemas.microsoft.com/office/drawing/2010/main">
-        <mc:Choice Requires="a14">
+      <mc:AlternateContent xmlns:mc="http://schemas.openxmlformats.org/markup-compatibility/2006">
+        <mc:Choice xmlns:a14="http://schemas.microsoft.com/office/drawing/2010/main" Requires="a14">
           <p:sp>
             <p:nvSpPr>
               <p:cNvPr id="3" name="Content Placeholder 2">
@@ -12689,14 +13558,18 @@
             </p:spPr>
             <p:txBody>
               <a:bodyPr anchor="ctr">
-                <a:normAutofit fontScale="92500" lnSpcReduction="10000"/>
+                <a:normAutofit fontScale="92500"/>
               </a:bodyPr>
               <a:lstStyle/>
               <a:p>
+                <a:r>
+                  <a:rPr lang="en-US" sz="1800" dirty="0"/>
+                  <a:t>Advantage of </a:t>
+                </a:r>
                 <a14:m>
                   <m:oMath xmlns:m="http://schemas.openxmlformats.org/officeDocument/2006/math">
                     <m:r>
-                      <a:rPr lang="en-US" sz="1800" b="0" i="1">
+                      <a:rPr lang="en-US" sz="1800" b="0" i="1" smtClean="0">
                         <a:latin typeface="Cambria Math" panose="02040503050406030204" pitchFamily="18" charset="0"/>
                       </a:rPr>
                       <m:t>𝑛</m:t>
@@ -12705,7 +13578,74 @@
                 </a14:m>
                 <a:r>
                   <a:rPr lang="en-US" sz="1800" dirty="0"/>
-                  <a:t>-step methods let us choose the amount of bootstrapping from 1-step to no bootstrapping (MC).</a:t>
+                  <a:t>-step over one-step methods: </a:t>
+                </a:r>
+              </a:p>
+              <a:p>
+                <a:pPr lvl="1"/>
+                <a:r>
+                  <a:rPr lang="en-US" sz="1800" b="1" dirty="0"/>
+                  <a:t>Learning</a:t>
+                </a:r>
+                <a:r>
+                  <a:rPr lang="en-US" sz="1800" dirty="0"/>
+                  <a:t>: Looking more steps ahead speeds up learning, especially for sparse rewards.</a:t>
+                </a:r>
+              </a:p>
+              <a:p>
+                <a:pPr lvl="1"/>
+                <a:r>
+                  <a:rPr lang="en-US" sz="1800" b="1" dirty="0"/>
+                  <a:t>Error reduction</a:t>
+                </a:r>
+                <a:r>
+                  <a:rPr lang="en-US" sz="1800" dirty="0"/>
+                  <a:t>: Significantly reduces the bootstrapping error (</a:t>
+                </a:r>
+                <a:r>
+                  <a:rPr lang="en-US" sz="1800" b="1" dirty="0"/>
+                  <a:t>bias</a:t>
+                </a:r>
+                <a:r>
+                  <a:rPr lang="en-US" sz="1800" dirty="0"/>
+                  <a:t>) at the cost of increased </a:t>
+                </a:r>
+                <a:r>
+                  <a:rPr lang="en-US" sz="1800" b="1" dirty="0"/>
+                  <a:t>variance</a:t>
+                </a:r>
+                <a:r>
+                  <a:rPr lang="en-US" sz="1800" dirty="0"/>
+                  <a:t>. </a:t>
+                </a:r>
+              </a:p>
+              <a:p>
+                <a:pPr lvl="1"/>
+                <a:r>
+                  <a:rPr lang="en-US" sz="1800" dirty="0"/>
+                  <a:t>An intermediate amount of bootstrapping typically </a:t>
+                </a:r>
+                <a:r>
+                  <a:rPr lang="en-US" sz="1800" b="1" dirty="0"/>
+                  <a:t>performs better</a:t>
+                </a:r>
+                <a:r>
+                  <a:rPr lang="en-US" sz="1800" dirty="0"/>
+                  <a:t> in terms of the variance/bias tradeoff than the one-step and MC extremes. </a:t>
+                </a:r>
+                <a14:m>
+                  <m:oMath xmlns:m="http://schemas.openxmlformats.org/officeDocument/2006/math">
+                    <m:r>
+                      <a:rPr lang="en-US" sz="1800" b="0" i="1">
+                        <a:latin typeface="Cambria Math" panose="02040503050406030204" pitchFamily="18" charset="0"/>
+                      </a:rPr>
+                      <m:t>𝑛</m:t>
+                    </m:r>
+                  </m:oMath>
+                </a14:m>
+                <a:r>
+                  <a:rPr lang="en-US" sz="1800" dirty="0"/>
+                  <a:t> is application-dependent and can be tuned.</a:t>
                 </a:r>
               </a:p>
               <a:p>
@@ -12714,108 +13654,46 @@
               <a:p>
                 <a:r>
                   <a:rPr lang="en-US" sz="1800" dirty="0"/>
-                  <a:t>Advantage over one-step methods: </a:t>
+                  <a:t>Drawbacks:</a:t>
                 </a:r>
               </a:p>
               <a:p>
                 <a:pPr lvl="1"/>
                 <a:r>
                   <a:rPr lang="en-US" sz="1800" b="1" dirty="0"/>
-                  <a:t>Learning</a:t>
+                  <a:t>Delay</a:t>
                 </a:r>
                 <a:r>
                   <a:rPr lang="en-US" sz="1800" dirty="0"/>
-                  <a:t>: Looking more steps ahead speeds up learning, especially for sparse rewards.</a:t>
-                </a:r>
-              </a:p>
-              <a:p>
-                <a:pPr lvl="1"/>
-                <a:r>
-                  <a:rPr lang="en-US" sz="1800" b="1" dirty="0"/>
-                  <a:t>Error reduction</a:t>
+                  <a:t>: </a:t>
+                </a:r>
+                <a:r>
+                  <a:rPr lang="en-US" sz="1800" dirty="0" err="1"/>
+                  <a:t>Updat</a:t>
                 </a:r>
                 <a:r>
                   <a:rPr lang="en-US" sz="1800" dirty="0"/>
-                  <a:t>: Significantly reduces the bootstrapping error (</a:t>
-                </a:r>
-                <a:r>
-                  <a:rPr lang="en-US" sz="1800" b="1" dirty="0"/>
-                  <a:t>bias</a:t>
-                </a:r>
-                <a:r>
-                  <a:rPr lang="en-US" sz="1800" dirty="0"/>
-                  <a:t>) at the cost of increased </a:t>
-                </a:r>
-                <a:r>
-                  <a:rPr lang="en-US" sz="1800" b="1" dirty="0"/>
-                  <a:t>variance</a:t>
-                </a:r>
-                <a:r>
-                  <a:rPr lang="en-US" sz="1800" dirty="0"/>
-                  <a:t>. </a:t>
-                </a:r>
-              </a:p>
-              <a:p>
-                <a:pPr lvl="1"/>
-                <a:r>
-                  <a:rPr lang="en-US" sz="1800" dirty="0"/>
-                  <a:t>An intermediate amount of bootstrapping typically </a:t>
-                </a:r>
-                <a:r>
-                  <a:rPr lang="en-US" sz="1800" b="1" dirty="0"/>
-                  <a:t>performs better</a:t>
-                </a:r>
-                <a:r>
-                  <a:rPr lang="en-US" sz="1800" dirty="0"/>
-                  <a:t> in terms of the variance/bias tradeoff than the one-step and MC extremes. </a:t>
+                  <a:t>es are delayed </a:t>
                 </a:r>
                 <a14:m>
                   <m:oMath xmlns:m="http://schemas.openxmlformats.org/officeDocument/2006/math">
                     <m:r>
-                      <a:rPr lang="en-US" sz="1800" b="0" i="1">
+                      <a:rPr lang="en-US" sz="1800" i="1">
                         <a:latin typeface="Cambria Math" panose="02040503050406030204" pitchFamily="18" charset="0"/>
                       </a:rPr>
                       <m:t>𝑛</m:t>
+                    </m:r>
+                    <m:r>
+                      <a:rPr lang="en-US" sz="1800" b="0" i="0" smtClean="0">
+                        <a:latin typeface="Cambria Math" panose="02040503050406030204" pitchFamily="18" charset="0"/>
+                      </a:rPr>
+                      <m:t> </m:t>
                     </m:r>
                   </m:oMath>
                 </a14:m>
                 <a:r>
                   <a:rPr lang="en-US" sz="1800" dirty="0"/>
-                  <a:t> is application-dependent and can be tuned.</a:t>
-                </a:r>
-              </a:p>
-              <a:p>
-                <a:endParaRPr lang="en-US" sz="1800" dirty="0"/>
-              </a:p>
-              <a:p>
-                <a:r>
-                  <a:rPr lang="en-US" sz="1800" dirty="0"/>
-                  <a:t>Drawback:</a:t>
-                </a:r>
-              </a:p>
-              <a:p>
-                <a:pPr lvl="1"/>
-                <a:r>
-                  <a:rPr lang="en-US" sz="1800" b="1" dirty="0"/>
-                  <a:t>Delay</a:t>
-                </a:r>
-                <a:r>
-                  <a:rPr lang="en-US" sz="1800" dirty="0"/>
-                  <a:t>: Updates are delayed </a:t>
-                </a:r>
-                <a14:m>
-                  <m:oMath xmlns:m="http://schemas.openxmlformats.org/officeDocument/2006/math">
-                    <m:r>
-                      <a:rPr lang="en-US" sz="1800" i="1">
-                        <a:latin typeface="Cambria Math" panose="02040503050406030204" pitchFamily="18" charset="0"/>
-                      </a:rPr>
-                      <m:t>𝑛</m:t>
-                    </m:r>
-                  </m:oMath>
-                </a14:m>
-                <a:r>
-                  <a:rPr lang="en-US" sz="1800" dirty="0"/>
-                  <a:t>-step since future events (rewards and states) are needed.</a:t>
+                  <a:t>steps since future events (rewards and states) are needed.</a:t>
                 </a:r>
               </a:p>
               <a:p>
@@ -12834,9 +13712,6 @@
                 <a:endParaRPr lang="en-US" sz="1800" dirty="0"/>
               </a:p>
               <a:p>
-                <a:pPr marL="0" indent="0">
-                  <a:buNone/>
-                </a:pPr>
                 <a:r>
                   <a:rPr lang="en-US" sz="1800" b="1" dirty="0"/>
                   <a:t>Eligibility traces </a:t>
@@ -12847,12 +13722,37 @@
                 </a:r>
               </a:p>
               <a:p>
-                <a:endParaRPr lang="en-US" sz="1400" dirty="0"/>
+                <a:r>
+                  <a:rPr lang="en-US" sz="1800" dirty="0"/>
+                  <a:t>Modern </a:t>
+                </a:r>
+                <a:r>
+                  <a:rPr lang="en-US" sz="1800" b="1" dirty="0"/>
+                  <a:t>Deep Reinforcement Learning </a:t>
+                </a:r>
+                <a:r>
+                  <a:rPr lang="en-US" sz="1800" dirty="0"/>
+                  <a:t>cannot use eligibility traces and goes back to </a:t>
+                </a:r>
+                <a14:m>
+                  <m:oMath xmlns:m="http://schemas.openxmlformats.org/officeDocument/2006/math">
+                    <m:r>
+                      <a:rPr lang="en-US" sz="1800" b="0" i="1" smtClean="0">
+                        <a:latin typeface="Cambria Math" panose="02040503050406030204" pitchFamily="18" charset="0"/>
+                      </a:rPr>
+                      <m:t>𝑛</m:t>
+                    </m:r>
+                  </m:oMath>
+                </a14:m>
+                <a:r>
+                  <a:rPr lang="en-US" sz="1800" dirty="0"/>
+                  <a:t>-step methods.</a:t>
+                </a:r>
               </a:p>
             </p:txBody>
           </p:sp>
         </mc:Choice>
-        <mc:Fallback xmlns="">
+        <mc:Fallback>
           <p:sp>
             <p:nvSpPr>
               <p:cNvPr id="3" name="Content Placeholder 2">
@@ -12877,7 +13777,7 @@
               <a:blipFill>
                 <a:blip r:embed="rId3"/>
                 <a:stretch>
-                  <a:fillRect l="-649" t="-919"/>
+                  <a:fillRect l="-541" b="-715"/>
                 </a:stretch>
               </a:blipFill>
             </p:spPr>
@@ -12942,7 +13842,7 @@
                                         <p:tgtEl>
                                           <p:spTgt spid="3">
                                             <p:txEl>
-                                              <p:pRg st="2" end="2"/>
+                                              <p:pRg st="0" end="0"/>
                                             </p:txEl>
                                           </p:spTgt>
                                         </p:tgtEl>
@@ -12973,7 +13873,7 @@
                                         <p:tgtEl>
                                           <p:spTgt spid="3">
                                             <p:txEl>
-                                              <p:pRg st="3" end="3"/>
+                                              <p:pRg st="1" end="1"/>
                                             </p:txEl>
                                           </p:spTgt>
                                         </p:tgtEl>
@@ -13004,7 +13904,7 @@
                                         <p:tgtEl>
                                           <p:spTgt spid="3">
                                             <p:txEl>
-                                              <p:pRg st="4" end="4"/>
+                                              <p:pRg st="2" end="2"/>
                                             </p:txEl>
                                           </p:spTgt>
                                         </p:tgtEl>
@@ -13035,7 +13935,7 @@
                                         <p:tgtEl>
                                           <p:spTgt spid="3">
                                             <p:txEl>
-                                              <p:pRg st="5" end="5"/>
+                                              <p:pRg st="3" end="3"/>
                                             </p:txEl>
                                           </p:spTgt>
                                         </p:tgtEl>
@@ -13084,7 +13984,7 @@
                                         <p:tgtEl>
                                           <p:spTgt spid="3">
                                             <p:txEl>
-                                              <p:pRg st="7" end="7"/>
+                                              <p:pRg st="5" end="5"/>
                                             </p:txEl>
                                           </p:spTgt>
                                         </p:tgtEl>
@@ -13115,7 +14015,7 @@
                                         <p:tgtEl>
                                           <p:spTgt spid="3">
                                             <p:txEl>
-                                              <p:pRg st="8" end="8"/>
+                                              <p:pRg st="6" end="6"/>
                                             </p:txEl>
                                           </p:spTgt>
                                         </p:tgtEl>
@@ -13146,7 +14046,7 @@
                                         <p:tgtEl>
                                           <p:spTgt spid="3">
                                             <p:txEl>
-                                              <p:pRg st="9" end="9"/>
+                                              <p:pRg st="7" end="7"/>
                                             </p:txEl>
                                           </p:spTgt>
                                         </p:tgtEl>
@@ -13195,7 +14095,38 @@
                                         <p:tgtEl>
                                           <p:spTgt spid="3">
                                             <p:txEl>
-                                              <p:pRg st="11" end="11"/>
+                                              <p:pRg st="9" end="9"/>
+                                            </p:txEl>
+                                          </p:spTgt>
+                                        </p:tgtEl>
+                                        <p:attrNameLst>
+                                          <p:attrName>style.visibility</p:attrName>
+                                        </p:attrNameLst>
+                                      </p:cBhvr>
+                                      <p:to>
+                                        <p:strVal val="visible"/>
+                                      </p:to>
+                                    </p:set>
+                                  </p:childTnLst>
+                                </p:cTn>
+                              </p:par>
+                              <p:par>
+                                <p:cTn id="25" presetID="1" presetClass="entr" presetSubtype="0" fill="hold" nodeType="withEffect">
+                                  <p:stCondLst>
+                                    <p:cond delay="0"/>
+                                  </p:stCondLst>
+                                  <p:childTnLst>
+                                    <p:set>
+                                      <p:cBhvr>
+                                        <p:cTn id="26" dur="1" fill="hold">
+                                          <p:stCondLst>
+                                            <p:cond delay="0"/>
+                                          </p:stCondLst>
+                                        </p:cTn>
+                                        <p:tgtEl>
+                                          <p:spTgt spid="3">
+                                            <p:txEl>
+                                              <p:pRg st="10" end="10"/>
                                             </p:txEl>
                                           </p:spTgt>
                                         </p:tgtEl>
@@ -17272,8 +18203,8 @@
           </p:sp>
         </mc:Fallback>
       </mc:AlternateContent>
-      <mc:AlternateContent xmlns:mc="http://schemas.openxmlformats.org/markup-compatibility/2006">
-        <mc:Choice xmlns:a14="http://schemas.microsoft.com/office/drawing/2010/main" Requires="a14">
+      <mc:AlternateContent xmlns:mc="http://schemas.openxmlformats.org/markup-compatibility/2006" xmlns:a14="http://schemas.microsoft.com/office/drawing/2010/main">
+        <mc:Choice Requires="a14">
           <p:sp>
             <p:nvSpPr>
               <p:cNvPr id="3" name="Content Placeholder 2">
@@ -17389,7 +18320,7 @@
             </p:txBody>
           </p:sp>
         </mc:Choice>
-        <mc:Fallback>
+        <mc:Fallback xmlns="">
           <p:sp>
             <p:nvSpPr>
               <p:cNvPr id="3" name="Content Placeholder 2">
@@ -17433,8 +18364,8 @@
           </p:sp>
         </mc:Fallback>
       </mc:AlternateContent>
-      <mc:AlternateContent xmlns:mc="http://schemas.openxmlformats.org/markup-compatibility/2006">
-        <mc:Choice xmlns:a14="http://schemas.microsoft.com/office/drawing/2010/main" Requires="a14">
+      <mc:AlternateContent xmlns:mc="http://schemas.openxmlformats.org/markup-compatibility/2006" xmlns:a14="http://schemas.microsoft.com/office/drawing/2010/main">
+        <mc:Choice Requires="a14">
           <p:sp>
             <p:nvSpPr>
               <p:cNvPr id="32" name="TextBox 31">
@@ -17528,7 +18459,7 @@
             </p:txBody>
           </p:sp>
         </mc:Choice>
-        <mc:Fallback>
+        <mc:Fallback xmlns="">
           <p:sp>
             <p:nvSpPr>
               <p:cNvPr id="32" name="TextBox 31">
@@ -21948,8 +22879,8 @@
           </p:sp>
         </mc:Fallback>
       </mc:AlternateContent>
-      <mc:AlternateContent xmlns:mc="http://schemas.openxmlformats.org/markup-compatibility/2006">
-        <mc:Choice xmlns:a14="http://schemas.microsoft.com/office/drawing/2010/main" Requires="a14">
+      <mc:AlternateContent xmlns:mc="http://schemas.openxmlformats.org/markup-compatibility/2006" xmlns:a14="http://schemas.microsoft.com/office/drawing/2010/main">
+        <mc:Choice Requires="a14">
           <p:sp>
             <p:nvSpPr>
               <p:cNvPr id="26" name="TextBox 25">
@@ -22101,7 +23032,7 @@
             </p:txBody>
           </p:sp>
         </mc:Choice>
-        <mc:Fallback>
+        <mc:Fallback xmlns="">
           <p:sp>
             <p:nvSpPr>
               <p:cNvPr id="26" name="TextBox 25">
@@ -23968,12 +24899,14 @@
         </p:nvSpPr>
         <p:spPr/>
         <p:txBody>
-          <a:bodyPr/>
+          <a:bodyPr>
+            <a:normAutofit/>
+          </a:bodyPr>
           <a:lstStyle/>
           <a:p>
             <a:r>
               <a:rPr lang="en-US" dirty="0"/>
-              <a:t>Convergence Guarantee</a:t>
+              <a:t>Error Reduction Property and Convergence</a:t>
             </a:r>
           </a:p>
         </p:txBody>
@@ -23999,7 +24932,7 @@
             <p:spPr>
               <a:xfrm>
                 <a:off x="770466" y="3606799"/>
-                <a:ext cx="10515600" cy="2844801"/>
+                <a:ext cx="10515600" cy="1888979"/>
               </a:xfrm>
             </p:spPr>
             <p:txBody>
@@ -24012,19 +24945,19 @@
                   <a:buNone/>
                 </a:pPr>
                 <a:r>
-                  <a:rPr lang="en-US" sz="2000" b="1" dirty="0"/>
+                  <a:rPr lang="en-US" sz="1800" b="1" dirty="0"/>
                   <a:t>Explanation</a:t>
                 </a:r>
                 <a:r>
-                  <a:rPr lang="en-US" sz="2000" dirty="0"/>
-                  <a:t>: </a:t>
+                  <a:rPr lang="en-US" sz="1800" dirty="0"/>
+                  <a:t> 	</a:t>
                 </a:r>
                 <a14:m>
                   <m:oMath xmlns:m="http://schemas.openxmlformats.org/officeDocument/2006/math">
                     <m:sSub>
                       <m:sSubPr>
                         <m:ctrlPr>
-                          <a:rPr lang="en-US" sz="2000" i="1">
+                          <a:rPr lang="en-US" sz="1800" i="1">
                             <a:latin typeface="Cambria Math" panose="02040503050406030204" pitchFamily="18" charset="0"/>
                             <a:ea typeface="Cambria Math" panose="02040503050406030204" pitchFamily="18" charset="0"/>
                           </a:rPr>
@@ -24032,7 +24965,7 @@
                       </m:sSubPr>
                       <m:e>
                         <m:r>
-                          <a:rPr lang="en-US" sz="2000" i="1">
+                          <a:rPr lang="en-US" sz="1800" i="1">
                             <a:latin typeface="Cambria Math" panose="02040503050406030204" pitchFamily="18" charset="0"/>
                             <a:ea typeface="Cambria Math" panose="02040503050406030204" pitchFamily="18" charset="0"/>
                           </a:rPr>
@@ -24041,35 +24974,35 @@
                       </m:e>
                       <m:sub>
                         <m:r>
-                          <a:rPr lang="en-US" sz="2000" i="1">
+                          <a:rPr lang="en-US" sz="1800" i="1">
                             <a:latin typeface="Cambria Math" panose="02040503050406030204" pitchFamily="18" charset="0"/>
                             <a:ea typeface="Cambria Math" panose="02040503050406030204" pitchFamily="18" charset="0"/>
                           </a:rPr>
                           <m:t>𝑡</m:t>
                         </m:r>
                         <m:r>
-                          <a:rPr lang="en-US" sz="2000" i="1">
+                          <a:rPr lang="en-US" sz="1800" i="1">
                             <a:latin typeface="Cambria Math" panose="02040503050406030204" pitchFamily="18" charset="0"/>
                             <a:ea typeface="Cambria Math" panose="02040503050406030204" pitchFamily="18" charset="0"/>
                           </a:rPr>
                           <m:t>:</m:t>
                         </m:r>
                         <m:r>
-                          <a:rPr lang="en-US" sz="2000" i="1">
+                          <a:rPr lang="en-US" sz="1800" i="1">
                             <a:latin typeface="Cambria Math" panose="02040503050406030204" pitchFamily="18" charset="0"/>
                             <a:ea typeface="Cambria Math" panose="02040503050406030204" pitchFamily="18" charset="0"/>
                           </a:rPr>
                           <m:t>𝑡</m:t>
                         </m:r>
                         <m:r>
-                          <a:rPr lang="en-US" sz="2000" i="1">
+                          <a:rPr lang="en-US" sz="1800" i="1">
                             <a:latin typeface="Cambria Math" panose="02040503050406030204" pitchFamily="18" charset="0"/>
                             <a:ea typeface="Cambria Math" panose="02040503050406030204" pitchFamily="18" charset="0"/>
                           </a:rPr>
                           <m:t>+</m:t>
                         </m:r>
                         <m:r>
-                          <a:rPr lang="en-US" sz="2000" i="1">
+                          <a:rPr lang="en-US" sz="1800" i="1">
                             <a:latin typeface="Cambria Math" panose="02040503050406030204" pitchFamily="18" charset="0"/>
                             <a:ea typeface="Cambria Math" panose="02040503050406030204" pitchFamily="18" charset="0"/>
                           </a:rPr>
@@ -24078,7 +25011,7 @@
                       </m:sub>
                     </m:sSub>
                     <m:r>
-                      <a:rPr lang="en-US" sz="2000" i="1">
+                      <a:rPr lang="en-US" sz="1800" i="1">
                         <a:latin typeface="Cambria Math" panose="02040503050406030204" pitchFamily="18" charset="0"/>
                       </a:rPr>
                       <m:t>=</m:t>
@@ -24086,14 +25019,14 @@
                     <m:sSub>
                       <m:sSubPr>
                         <m:ctrlPr>
-                          <a:rPr lang="en-US" sz="2000" i="1">
+                          <a:rPr lang="en-US" sz="1800" i="1">
                             <a:latin typeface="Cambria Math" panose="02040503050406030204" pitchFamily="18" charset="0"/>
                           </a:rPr>
                         </m:ctrlPr>
                       </m:sSubPr>
                       <m:e>
                         <m:r>
-                          <a:rPr lang="en-US" sz="2000" i="1">
+                          <a:rPr lang="en-US" sz="1800" i="1">
                             <a:latin typeface="Cambria Math" panose="02040503050406030204" pitchFamily="18" charset="0"/>
                           </a:rPr>
                           <m:t>𝑅</m:t>
@@ -24101,13 +25034,13 @@
                       </m:e>
                       <m:sub>
                         <m:r>
-                          <a:rPr lang="en-US" sz="2000" i="1">
+                          <a:rPr lang="en-US" sz="1800" i="1">
                             <a:latin typeface="Cambria Math" panose="02040503050406030204" pitchFamily="18" charset="0"/>
                           </a:rPr>
                           <m:t>𝑡</m:t>
                         </m:r>
                         <m:r>
-                          <a:rPr lang="en-US" sz="2000" i="1">
+                          <a:rPr lang="en-US" sz="1800" i="1">
                             <a:latin typeface="Cambria Math" panose="02040503050406030204" pitchFamily="18" charset="0"/>
                           </a:rPr>
                           <m:t>+1</m:t>
@@ -24115,13 +25048,13 @@
                       </m:sub>
                     </m:sSub>
                     <m:r>
-                      <a:rPr lang="en-US" sz="2000" i="1">
+                      <a:rPr lang="en-US" sz="1800" i="1">
                         <a:latin typeface="Cambria Math" panose="02040503050406030204" pitchFamily="18" charset="0"/>
                       </a:rPr>
                       <m:t>+</m:t>
                     </m:r>
                     <m:r>
-                      <a:rPr lang="en-US" sz="2000" i="1">
+                      <a:rPr lang="en-US" sz="1800" i="1">
                         <a:latin typeface="Cambria Math" panose="02040503050406030204" pitchFamily="18" charset="0"/>
                       </a:rPr>
                       <m:t>𝛾</m:t>
@@ -24129,14 +25062,14 @@
                     <m:sSub>
                       <m:sSubPr>
                         <m:ctrlPr>
-                          <a:rPr lang="en-US" sz="2000" i="1">
+                          <a:rPr lang="en-US" sz="1800" i="1">
                             <a:latin typeface="Cambria Math" panose="02040503050406030204" pitchFamily="18" charset="0"/>
                           </a:rPr>
                         </m:ctrlPr>
                       </m:sSubPr>
                       <m:e>
                         <m:r>
-                          <a:rPr lang="en-US" sz="2000" i="1">
+                          <a:rPr lang="en-US" sz="1800" i="1">
                             <a:latin typeface="Cambria Math" panose="02040503050406030204" pitchFamily="18" charset="0"/>
                           </a:rPr>
                           <m:t>𝑅</m:t>
@@ -24144,13 +25077,13 @@
                       </m:e>
                       <m:sub>
                         <m:r>
-                          <a:rPr lang="en-US" sz="2000" i="1">
+                          <a:rPr lang="en-US" sz="1800" i="1">
                             <a:latin typeface="Cambria Math" panose="02040503050406030204" pitchFamily="18" charset="0"/>
                           </a:rPr>
                           <m:t>𝑡</m:t>
                         </m:r>
                         <m:r>
-                          <a:rPr lang="en-US" sz="2000" i="1">
+                          <a:rPr lang="en-US" sz="1800" i="1">
                             <a:latin typeface="Cambria Math" panose="02040503050406030204" pitchFamily="18" charset="0"/>
                           </a:rPr>
                           <m:t>+2</m:t>
@@ -24158,7 +25091,7 @@
                       </m:sub>
                     </m:sSub>
                     <m:r>
-                      <a:rPr lang="en-US" sz="2000" i="1">
+                      <a:rPr lang="en-US" sz="1800" i="1">
                         <a:latin typeface="Cambria Math" panose="02040503050406030204" pitchFamily="18" charset="0"/>
                       </a:rPr>
                       <m:t>+…+</m:t>
@@ -24166,14 +25099,14 @@
                     <m:sSup>
                       <m:sSupPr>
                         <m:ctrlPr>
-                          <a:rPr lang="en-US" sz="2000" i="1">
+                          <a:rPr lang="en-US" sz="1800" i="1">
                             <a:latin typeface="Cambria Math" panose="02040503050406030204" pitchFamily="18" charset="0"/>
                           </a:rPr>
                         </m:ctrlPr>
                       </m:sSupPr>
                       <m:e>
                         <m:r>
-                          <a:rPr lang="en-US" sz="2000" i="1">
+                          <a:rPr lang="en-US" sz="1800" i="1">
                             <a:latin typeface="Cambria Math" panose="02040503050406030204" pitchFamily="18" charset="0"/>
                           </a:rPr>
                           <m:t>𝛾</m:t>
@@ -24181,13 +25114,13 @@
                       </m:e>
                       <m:sup>
                         <m:r>
-                          <a:rPr lang="en-US" sz="2000" i="1">
+                          <a:rPr lang="en-US" sz="1800" i="1">
                             <a:latin typeface="Cambria Math" panose="02040503050406030204" pitchFamily="18" charset="0"/>
                           </a:rPr>
                           <m:t>𝑛</m:t>
                         </m:r>
                         <m:r>
-                          <a:rPr lang="en-US" sz="2000" i="1">
+                          <a:rPr lang="en-US" sz="1800" i="1">
                             <a:latin typeface="Cambria Math" panose="02040503050406030204" pitchFamily="18" charset="0"/>
                           </a:rPr>
                           <m:t>−1</m:t>
@@ -24197,14 +25130,14 @@
                     <m:sSub>
                       <m:sSubPr>
                         <m:ctrlPr>
-                          <a:rPr lang="en-US" sz="2000" i="1">
+                          <a:rPr lang="en-US" sz="1800" i="1">
                             <a:latin typeface="Cambria Math" panose="02040503050406030204" pitchFamily="18" charset="0"/>
                           </a:rPr>
                         </m:ctrlPr>
                       </m:sSubPr>
                       <m:e>
                         <m:r>
-                          <a:rPr lang="en-US" sz="2000" i="1">
+                          <a:rPr lang="en-US" sz="1800" i="1">
                             <a:latin typeface="Cambria Math" panose="02040503050406030204" pitchFamily="18" charset="0"/>
                           </a:rPr>
                           <m:t>𝑅</m:t>
@@ -24212,19 +25145,19 @@
                       </m:e>
                       <m:sub>
                         <m:r>
-                          <a:rPr lang="en-US" sz="2000" i="1">
+                          <a:rPr lang="en-US" sz="1800" i="1">
                             <a:latin typeface="Cambria Math" panose="02040503050406030204" pitchFamily="18" charset="0"/>
                           </a:rPr>
                           <m:t>𝑡</m:t>
                         </m:r>
                         <m:r>
-                          <a:rPr lang="en-US" sz="2000" i="1">
+                          <a:rPr lang="en-US" sz="1800" i="1">
                             <a:latin typeface="Cambria Math" panose="02040503050406030204" pitchFamily="18" charset="0"/>
                           </a:rPr>
                           <m:t>+</m:t>
                         </m:r>
                         <m:r>
-                          <a:rPr lang="en-US" sz="2000" i="1">
+                          <a:rPr lang="en-US" sz="1800" i="1">
                             <a:latin typeface="Cambria Math" panose="02040503050406030204" pitchFamily="18" charset="0"/>
                           </a:rPr>
                           <m:t>𝑛</m:t>
@@ -24232,7 +25165,7 @@
                       </m:sub>
                     </m:sSub>
                     <m:r>
-                      <a:rPr lang="en-US" sz="2000" i="1">
+                      <a:rPr lang="en-US" sz="1800" i="1">
                         <a:latin typeface="Cambria Math" panose="02040503050406030204" pitchFamily="18" charset="0"/>
                       </a:rPr>
                       <m:t>+</m:t>
@@ -24240,14 +25173,14 @@
                     <m:sSup>
                       <m:sSupPr>
                         <m:ctrlPr>
-                          <a:rPr lang="en-US" sz="2000" i="1">
+                          <a:rPr lang="en-US" sz="1800" i="1">
                             <a:latin typeface="Cambria Math" panose="02040503050406030204" pitchFamily="18" charset="0"/>
                           </a:rPr>
                         </m:ctrlPr>
                       </m:sSupPr>
                       <m:e>
                         <m:r>
-                          <a:rPr lang="en-US" sz="2000" i="1">
+                          <a:rPr lang="en-US" sz="1800" i="1">
                             <a:latin typeface="Cambria Math" panose="02040503050406030204" pitchFamily="18" charset="0"/>
                           </a:rPr>
                           <m:t>𝛾</m:t>
@@ -24255,7 +25188,7 @@
                       </m:e>
                       <m:sup>
                         <m:r>
-                          <a:rPr lang="en-US" sz="2000" i="1">
+                          <a:rPr lang="en-US" sz="1800" i="1">
                             <a:latin typeface="Cambria Math" panose="02040503050406030204" pitchFamily="18" charset="0"/>
                           </a:rPr>
                           <m:t>𝑛</m:t>
@@ -24263,7 +25196,7 @@
                       </m:sup>
                     </m:sSup>
                     <m:r>
-                      <a:rPr lang="en-US" sz="2000" i="1">
+                      <a:rPr lang="en-US" sz="1800" i="1">
                         <a:latin typeface="Cambria Math" panose="02040503050406030204" pitchFamily="18" charset="0"/>
                       </a:rPr>
                       <m:t>𝑉</m:t>
@@ -24271,7 +25204,7 @@
                     <m:d>
                       <m:dPr>
                         <m:ctrlPr>
-                          <a:rPr lang="en-US" sz="2000" i="1">
+                          <a:rPr lang="en-US" sz="1800" i="1">
                             <a:latin typeface="Cambria Math" panose="02040503050406030204" pitchFamily="18" charset="0"/>
                           </a:rPr>
                         </m:ctrlPr>
@@ -24280,14 +25213,14 @@
                         <m:sSub>
                           <m:sSubPr>
                             <m:ctrlPr>
-                              <a:rPr lang="en-US" sz="2000" i="1">
+                              <a:rPr lang="en-US" sz="1800" i="1">
                                 <a:latin typeface="Cambria Math" panose="02040503050406030204" pitchFamily="18" charset="0"/>
                               </a:rPr>
                             </m:ctrlPr>
                           </m:sSubPr>
                           <m:e>
                             <m:r>
-                              <a:rPr lang="en-US" sz="2000" i="1">
+                              <a:rPr lang="en-US" sz="1800" i="1">
                                 <a:latin typeface="Cambria Math" panose="02040503050406030204" pitchFamily="18" charset="0"/>
                               </a:rPr>
                               <m:t>𝑆</m:t>
@@ -24295,19 +25228,19 @@
                           </m:e>
                           <m:sub>
                             <m:r>
-                              <a:rPr lang="en-US" sz="2000" i="1">
+                              <a:rPr lang="en-US" sz="1800" i="1">
                                 <a:latin typeface="Cambria Math" panose="02040503050406030204" pitchFamily="18" charset="0"/>
                               </a:rPr>
                               <m:t>𝑡</m:t>
                             </m:r>
                             <m:r>
-                              <a:rPr lang="en-US" sz="2000" i="1">
+                              <a:rPr lang="en-US" sz="1800" i="1">
                                 <a:latin typeface="Cambria Math" panose="02040503050406030204" pitchFamily="18" charset="0"/>
                               </a:rPr>
                               <m:t>+</m:t>
                             </m:r>
                             <m:r>
-                              <a:rPr lang="en-US" sz="2000" i="1">
+                              <a:rPr lang="en-US" sz="1800" i="1">
                                 <a:latin typeface="Cambria Math" panose="02040503050406030204" pitchFamily="18" charset="0"/>
                               </a:rPr>
                               <m:t>𝑛</m:t>
@@ -24318,25 +25251,23 @@
                     </m:d>
                   </m:oMath>
                 </a14:m>
-                <a:endParaRPr lang="en-US" sz="2000" dirty="0"/>
+                <a:endParaRPr lang="en-US" sz="1800" dirty="0"/>
               </a:p>
               <a:p>
-                <a:pPr lvl="1"/>
-                <a:r>
-                  <a:rPr lang="en-US" sz="1600" dirty="0"/>
-                  <a:t>Observed rewards have in expectation no error.</a:t>
+                <a:r>
+                  <a:rPr lang="en-US" sz="1800" dirty="0"/>
+                  <a:t>The averages of observed rewards have in expectation no error (are unbiased).</a:t>
                 </a:r>
               </a:p>
               <a:p>
-                <a:pPr lvl="1"/>
-                <a:r>
-                  <a:rPr lang="en-US" sz="1600" dirty="0"/>
-                  <a:t>The error-prone bootstrap estimate is smaller because it is </a:t>
+                <a:r>
+                  <a:rPr lang="en-US" sz="1800" dirty="0"/>
+                  <a:t>The impact of the error-prone bootstrap estimate is smaller because it is </a:t>
                 </a:r>
                 <a14:m>
                   <m:oMath xmlns:m="http://schemas.openxmlformats.org/officeDocument/2006/math">
                     <m:r>
-                      <a:rPr lang="en-US" sz="1600" b="0" i="1" smtClean="0">
+                      <a:rPr lang="en-US" sz="1800" b="0" i="1" smtClean="0">
                         <a:latin typeface="Cambria Math" panose="02040503050406030204" pitchFamily="18" charset="0"/>
                       </a:rPr>
                       <m:t>𝑛</m:t>
@@ -24344,80 +25275,61 @@
                   </m:oMath>
                 </a14:m>
                 <a:r>
-                  <a:rPr lang="en-US" sz="1600" dirty="0"/>
-                  <a:t> time steps away and thus discounted.</a:t>
+                  <a:rPr lang="en-US" sz="1800" dirty="0"/>
+                  <a:t> time steps away and thus discounted by </a:t>
+                </a:r>
+                <a14:m>
+                  <m:oMath xmlns:m="http://schemas.openxmlformats.org/officeDocument/2006/math">
+                    <m:sSup>
+                      <m:sSupPr>
+                        <m:ctrlPr>
+                          <a:rPr lang="en-US" sz="1800" b="0" i="1" smtClean="0">
+                            <a:latin typeface="Cambria Math" panose="02040503050406030204" pitchFamily="18" charset="0"/>
+                          </a:rPr>
+                        </m:ctrlPr>
+                      </m:sSupPr>
+                      <m:e>
+                        <m:r>
+                          <a:rPr lang="en-US" sz="1800" b="0" i="1" smtClean="0">
+                            <a:latin typeface="Cambria Math" panose="02040503050406030204" pitchFamily="18" charset="0"/>
+                          </a:rPr>
+                          <m:t>𝛾</m:t>
+                        </m:r>
+                      </m:e>
+                      <m:sup>
+                        <m:r>
+                          <a:rPr lang="en-US" sz="1800" b="0" i="1" smtClean="0">
+                            <a:latin typeface="Cambria Math" panose="02040503050406030204" pitchFamily="18" charset="0"/>
+                          </a:rPr>
+                          <m:t>𝑛</m:t>
+                        </m:r>
+                      </m:sup>
+                    </m:sSup>
+                  </m:oMath>
+                </a14:m>
+                <a:r>
+                  <a:rPr lang="en-US" sz="1800" dirty="0"/>
+                  <a:t> (related to </a:t>
+                </a:r>
+                <a14:m>
+                  <m:oMath xmlns:m="http://schemas.openxmlformats.org/officeDocument/2006/math">
+                    <m:r>
+                      <a:rPr lang="en-US" sz="1800" b="0" i="1" smtClean="0">
+                        <a:latin typeface="Cambria Math" panose="02040503050406030204" pitchFamily="18" charset="0"/>
+                      </a:rPr>
+                      <m:t>𝛾</m:t>
+                    </m:r>
+                  </m:oMath>
+                </a14:m>
+                <a:r>
+                  <a:rPr lang="en-US" sz="1800" dirty="0"/>
+                  <a:t>-contracting property of Bellman updates).</a:t>
                 </a:r>
               </a:p>
               <a:p>
-                <a:pPr lvl="1"/>
-                <a:r>
-                  <a:rPr lang="en-US" sz="1600" dirty="0"/>
-                  <a:t>Increasing </a:t>
-                </a:r>
-                <a14:m>
-                  <m:oMath xmlns:m="http://schemas.openxmlformats.org/officeDocument/2006/math">
-                    <m:r>
-                      <a:rPr lang="en-US" sz="1600" b="0" i="1" smtClean="0">
-                        <a:latin typeface="Cambria Math" panose="02040503050406030204" pitchFamily="18" charset="0"/>
-                      </a:rPr>
-                      <m:t>𝑛</m:t>
-                    </m:r>
-                  </m:oMath>
-                </a14:m>
-                <a:r>
-                  <a:rPr lang="en-US" sz="1600" dirty="0"/>
-                  <a:t> adds more observed rewards decreases the impact of the bootstrapping error. </a:t>
-                </a:r>
-              </a:p>
-              <a:p>
-                <a:pPr marL="0" indent="0" algn="ctr">
-                  <a:buNone/>
-                </a:pPr>
-                <a:endParaRPr lang="en-US" sz="2000" dirty="0"/>
-              </a:p>
-              <a:p>
-                <a:pPr marL="0" indent="0">
-                  <a:buNone/>
-                </a:pPr>
-                <a:r>
-                  <a:rPr lang="en-US" sz="2000" b="1" dirty="0"/>
-                  <a:t>Note</a:t>
-                </a:r>
-                <a:r>
-                  <a:rPr lang="en-US" sz="2000" dirty="0"/>
-                  <a:t>: This also means that every update is guaranteed to reduce the expected error and moves the estimate closer to the true value function. </a:t>
-                </a:r>
-                <a:br>
-                  <a:rPr lang="en-US" sz="2000" dirty="0"/>
-                </a:br>
-                <a:br>
-                  <a:rPr lang="en-US" sz="2000" dirty="0"/>
-                </a:br>
-                <a:r>
-                  <a:rPr lang="en-US" sz="2000" dirty="0"/>
-                  <a:t>		</a:t>
-                </a:r>
-                <a:r>
-                  <a:rPr lang="en-US" sz="2000" b="1" dirty="0"/>
-                  <a:t>All </a:t>
-                </a:r>
-                <a14:m>
-                  <m:oMath xmlns:m="http://schemas.openxmlformats.org/officeDocument/2006/math">
-                    <m:r>
-                      <a:rPr lang="en-US" sz="2000" b="1" i="1" dirty="0">
-                        <a:latin typeface="Cambria Math" panose="02040503050406030204" pitchFamily="18" charset="0"/>
-                      </a:rPr>
-                      <m:t>𝒏</m:t>
-                    </m:r>
-                  </m:oMath>
-                </a14:m>
-                <a:r>
-                  <a:rPr lang="en-US" sz="2000" b="1" dirty="0"/>
-                  <a:t>-step methods (including 1-step and MC) converge</a:t>
-                </a:r>
-                <a:r>
-                  <a:rPr lang="en-US" sz="2000" dirty="0"/>
-                  <a:t>!</a:t>
+                <a:r>
+                  <a:rPr lang="en-US" sz="1800" dirty="0"/>
+                  <a:t>Expectation just means we need many estimates (= use many episodes)</a:t>
                 </a:r>
               </a:p>
             </p:txBody>
@@ -24443,12 +25355,12 @@
             <p:spPr>
               <a:xfrm>
                 <a:off x="770466" y="3606799"/>
-                <a:ext cx="10515600" cy="2844801"/>
+                <a:ext cx="10515600" cy="1888979"/>
               </a:xfrm>
               <a:blipFill>
                 <a:blip r:embed="rId2"/>
                 <a:stretch>
-                  <a:fillRect l="-580" t="-2146" r="-986" b="-4077"/>
+                  <a:fillRect l="-464" t="-2903"/>
                 </a:stretch>
               </a:blipFill>
             </p:spPr>
@@ -24483,8 +25395,8 @@
             </p:nvSpPr>
             <p:spPr>
               <a:xfrm>
-                <a:off x="2142066" y="1252872"/>
-                <a:ext cx="7467483" cy="2033827"/>
+                <a:off x="2072082" y="1252872"/>
+                <a:ext cx="7743038" cy="2033827"/>
               </a:xfrm>
               <a:prstGeom prst="rect">
                 <a:avLst/>
@@ -24540,69 +25452,7 @@
               <a:p>
                 <a:r>
                   <a:rPr lang="en-US" sz="2000" dirty="0"/>
-                  <a:t>The worst error of the expected </a:t>
-                </a:r>
-                <a14:m>
-                  <m:oMath xmlns:m="http://schemas.openxmlformats.org/officeDocument/2006/math">
-                    <m:r>
-                      <a:rPr lang="en-US" sz="2000" i="1" dirty="0" smtClean="0">
-                        <a:latin typeface="Cambria Math" panose="02040503050406030204" pitchFamily="18" charset="0"/>
-                      </a:rPr>
-                      <m:t>𝑛</m:t>
-                    </m:r>
-                  </m:oMath>
-                </a14:m>
-                <a:r>
-                  <a:rPr lang="en-US" sz="2000" dirty="0"/>
-                  <a:t>-step return is guaranteed to be less than or equal to </a:t>
-                </a:r>
-                <a14:m>
-                  <m:oMath xmlns:m="http://schemas.openxmlformats.org/officeDocument/2006/math">
-                    <m:sSup>
-                      <m:sSupPr>
-                        <m:ctrlPr>
-                          <a:rPr lang="en-US" sz="2000" b="0" i="1" smtClean="0">
-                            <a:latin typeface="Cambria Math" panose="02040503050406030204" pitchFamily="18" charset="0"/>
-                          </a:rPr>
-                        </m:ctrlPr>
-                      </m:sSupPr>
-                      <m:e>
-                        <m:r>
-                          <a:rPr lang="en-US" sz="2000" b="0" i="1" smtClean="0">
-                            <a:latin typeface="Cambria Math" panose="02040503050406030204" pitchFamily="18" charset="0"/>
-                          </a:rPr>
-                          <m:t>𝛾</m:t>
-                        </m:r>
-                      </m:e>
-                      <m:sup>
-                        <m:r>
-                          <a:rPr lang="en-US" sz="2000" b="0" i="1" smtClean="0">
-                            <a:latin typeface="Cambria Math" panose="02040503050406030204" pitchFamily="18" charset="0"/>
-                          </a:rPr>
-                          <m:t>𝑛</m:t>
-                        </m:r>
-                      </m:sup>
-                    </m:sSup>
-                  </m:oMath>
-                </a14:m>
-                <a:r>
-                  <a:rPr lang="en-US" sz="2000" dirty="0"/>
-                  <a:t> times the worst error of using </a:t>
-                </a:r>
-                <a14:m>
-                  <m:oMath xmlns:m="http://schemas.openxmlformats.org/officeDocument/2006/math">
-                    <m:r>
-                      <a:rPr lang="en-US" sz="2000" b="0" i="1" smtClean="0">
-                        <a:latin typeface="Cambria Math" panose="02040503050406030204" pitchFamily="18" charset="0"/>
-                        <a:ea typeface="Cambria Math" panose="02040503050406030204" pitchFamily="18" charset="0"/>
-                      </a:rPr>
-                      <m:t>𝑉</m:t>
-                    </m:r>
-                  </m:oMath>
-                </a14:m>
-                <a:r>
-                  <a:rPr lang="en-US" sz="2000" dirty="0"/>
-                  <a:t>.</a:t>
+                  <a:t>The expected value of n-step returns is always better than the current approximation (for the worst state).</a:t>
                 </a:r>
               </a:p>
               <a:p>
@@ -24659,7 +25509,7 @@
                               <m:begChr m:val="|"/>
                               <m:endChr m:val="|"/>
                               <m:ctrlPr>
-                                <a:rPr lang="en-US" sz="2000" b="0" i="1" smtClean="0">
+                                <a:rPr lang="en-US" sz="2000" i="1" smtClean="0">
                                   <a:latin typeface="Cambria Math" panose="02040503050406030204" pitchFamily="18" charset="0"/>
                                   <a:ea typeface="Cambria Math" panose="02040503050406030204" pitchFamily="18" charset="0"/>
                                 </a:rPr>
@@ -25059,8 +25909,8 @@
             </p:nvSpPr>
             <p:spPr>
               <a:xfrm>
-                <a:off x="2142066" y="1252872"/>
-                <a:ext cx="7467483" cy="2033827"/>
+                <a:off x="2072082" y="1252872"/>
+                <a:ext cx="7743038" cy="2033827"/>
               </a:xfrm>
               <a:prstGeom prst="rect">
                 <a:avLst/>
@@ -25068,7 +25918,121 @@
               <a:blipFill>
                 <a:blip r:embed="rId3"/>
                 <a:stretch>
-                  <a:fillRect l="-733" t="-1190"/>
+                  <a:fillRect l="-786" t="-1190" r="-943"/>
+                </a:stretch>
+              </a:blipFill>
+            </p:spPr>
+            <p:txBody>
+              <a:bodyPr/>
+              <a:lstStyle/>
+              <a:p>
+                <a:r>
+                  <a:rPr lang="en-US">
+                    <a:noFill/>
+                  </a:rPr>
+                  <a:t> </a:t>
+                </a:r>
+              </a:p>
+            </p:txBody>
+          </p:sp>
+        </mc:Fallback>
+      </mc:AlternateContent>
+      <mc:AlternateContent xmlns:mc="http://schemas.openxmlformats.org/markup-compatibility/2006" xmlns:a14="http://schemas.microsoft.com/office/drawing/2010/main">
+        <mc:Choice Requires="a14">
+          <p:sp>
+            <p:nvSpPr>
+              <p:cNvPr id="6" name="TextBox 5">
+                <a:extLst>
+                  <a:ext uri="{FF2B5EF4-FFF2-40B4-BE49-F238E27FC236}">
+                    <a16:creationId xmlns:a16="http://schemas.microsoft.com/office/drawing/2014/main" id="{9D5E86A9-F4CE-EE45-120B-538532B55D95}"/>
+                  </a:ext>
+                </a:extLst>
+              </p:cNvPr>
+              <p:cNvSpPr txBox="1"/>
+              <p:nvPr/>
+            </p:nvSpPr>
+            <p:spPr>
+              <a:xfrm>
+                <a:off x="2072082" y="5689862"/>
+                <a:ext cx="7743038" cy="400110"/>
+              </a:xfrm>
+              <a:prstGeom prst="rect">
+                <a:avLst/>
+              </a:prstGeom>
+            </p:spPr>
+            <p:style>
+              <a:lnRef idx="2">
+                <a:schemeClr val="accent2">
+                  <a:shade val="15000"/>
+                </a:schemeClr>
+              </a:lnRef>
+              <a:fillRef idx="1">
+                <a:schemeClr val="accent2"/>
+              </a:fillRef>
+              <a:effectRef idx="0">
+                <a:schemeClr val="accent2"/>
+              </a:effectRef>
+              <a:fontRef idx="minor">
+                <a:schemeClr val="lt1"/>
+              </a:fontRef>
+            </p:style>
+            <p:txBody>
+              <a:bodyPr wrap="square">
+                <a:spAutoFit/>
+              </a:bodyPr>
+              <a:lstStyle/>
+              <a:p>
+                <a:pPr algn="ctr"/>
+                <a:r>
+                  <a:rPr lang="en-US" sz="2000" dirty="0"/>
+                  <a:t>Implication: All </a:t>
+                </a:r>
+                <a14:m>
+                  <m:oMath xmlns:m="http://schemas.openxmlformats.org/officeDocument/2006/math">
+                    <m:r>
+                      <a:rPr lang="en-US" sz="2000" b="0" i="1" dirty="0">
+                        <a:latin typeface="Cambria Math" panose="02040503050406030204" pitchFamily="18" charset="0"/>
+                      </a:rPr>
+                      <m:t>𝑛</m:t>
+                    </m:r>
+                  </m:oMath>
+                </a14:m>
+                <a:r>
+                  <a:rPr lang="en-US" sz="2000" dirty="0"/>
+                  <a:t>-step methods (including 1-step and MC) converge!</a:t>
+                </a:r>
+                <a:endParaRPr lang="en-US" dirty="0"/>
+              </a:p>
+            </p:txBody>
+          </p:sp>
+        </mc:Choice>
+        <mc:Fallback xmlns="">
+          <p:sp>
+            <p:nvSpPr>
+              <p:cNvPr id="6" name="TextBox 5">
+                <a:extLst>
+                  <a:ext uri="{FF2B5EF4-FFF2-40B4-BE49-F238E27FC236}">
+                    <a16:creationId xmlns:a16="http://schemas.microsoft.com/office/drawing/2014/main" id="{9D5E86A9-F4CE-EE45-120B-538532B55D95}"/>
+                  </a:ext>
+                </a:extLst>
+              </p:cNvPr>
+              <p:cNvSpPr txBox="1">
+                <a:spLocks noRot="1" noChangeAspect="1" noMove="1" noResize="1" noEditPoints="1" noAdjustHandles="1" noChangeArrowheads="1" noChangeShapeType="1" noTextEdit="1"/>
+              </p:cNvSpPr>
+              <p:nvPr/>
+            </p:nvSpPr>
+            <p:spPr>
+              <a:xfrm>
+                <a:off x="2072082" y="5689862"/>
+                <a:ext cx="7743038" cy="400110"/>
+              </a:xfrm>
+              <a:prstGeom prst="rect">
+                <a:avLst/>
+              </a:prstGeom>
+              <a:blipFill>
+                <a:blip r:embed="rId4"/>
+                <a:stretch>
+                  <a:fillRect t="-4348" b="-23188"/>
                 </a:stretch>
               </a:blipFill>
             </p:spPr>
@@ -25097,6 +26061,280 @@
   <p:clrMapOvr>
     <a:masterClrMapping/>
   </p:clrMapOvr>
+  <p:timing>
+    <p:tnLst>
+      <p:par>
+        <p:cTn id="1" dur="indefinite" restart="never" nodeType="tmRoot">
+          <p:childTnLst>
+            <p:seq concurrent="1" nextAc="seek">
+              <p:cTn id="2" dur="indefinite" nodeType="mainSeq">
+                <p:childTnLst>
+                  <p:par>
+                    <p:cTn id="3" fill="hold">
+                      <p:stCondLst>
+                        <p:cond delay="indefinite"/>
+                      </p:stCondLst>
+                      <p:childTnLst>
+                        <p:par>
+                          <p:cTn id="4" fill="hold">
+                            <p:stCondLst>
+                              <p:cond delay="0"/>
+                            </p:stCondLst>
+                            <p:childTnLst>
+                              <p:par>
+                                <p:cTn id="5" presetID="1" presetClass="entr" presetSubtype="0" fill="hold" nodeType="clickEffect">
+                                  <p:stCondLst>
+                                    <p:cond delay="0"/>
+                                  </p:stCondLst>
+                                  <p:childTnLst>
+                                    <p:set>
+                                      <p:cBhvr>
+                                        <p:cTn id="6" dur="1" fill="hold">
+                                          <p:stCondLst>
+                                            <p:cond delay="0"/>
+                                          </p:stCondLst>
+                                        </p:cTn>
+                                        <p:tgtEl>
+                                          <p:spTgt spid="3">
+                                            <p:txEl>
+                                              <p:pRg st="0" end="0"/>
+                                            </p:txEl>
+                                          </p:spTgt>
+                                        </p:tgtEl>
+                                        <p:attrNameLst>
+                                          <p:attrName>style.visibility</p:attrName>
+                                        </p:attrNameLst>
+                                      </p:cBhvr>
+                                      <p:to>
+                                        <p:strVal val="visible"/>
+                                      </p:to>
+                                    </p:set>
+                                  </p:childTnLst>
+                                </p:cTn>
+                              </p:par>
+                            </p:childTnLst>
+                          </p:cTn>
+                        </p:par>
+                      </p:childTnLst>
+                    </p:cTn>
+                  </p:par>
+                  <p:par>
+                    <p:cTn id="7" fill="hold">
+                      <p:stCondLst>
+                        <p:cond delay="indefinite"/>
+                      </p:stCondLst>
+                      <p:childTnLst>
+                        <p:par>
+                          <p:cTn id="8" fill="hold">
+                            <p:stCondLst>
+                              <p:cond delay="0"/>
+                            </p:stCondLst>
+                            <p:childTnLst>
+                              <p:par>
+                                <p:cTn id="9" presetID="1" presetClass="entr" presetSubtype="0" fill="hold" nodeType="clickEffect">
+                                  <p:stCondLst>
+                                    <p:cond delay="0"/>
+                                  </p:stCondLst>
+                                  <p:childTnLst>
+                                    <p:set>
+                                      <p:cBhvr>
+                                        <p:cTn id="10" dur="1" fill="hold">
+                                          <p:stCondLst>
+                                            <p:cond delay="0"/>
+                                          </p:stCondLst>
+                                        </p:cTn>
+                                        <p:tgtEl>
+                                          <p:spTgt spid="3">
+                                            <p:txEl>
+                                              <p:pRg st="1" end="1"/>
+                                            </p:txEl>
+                                          </p:spTgt>
+                                        </p:tgtEl>
+                                        <p:attrNameLst>
+                                          <p:attrName>style.visibility</p:attrName>
+                                        </p:attrNameLst>
+                                      </p:cBhvr>
+                                      <p:to>
+                                        <p:strVal val="visible"/>
+                                      </p:to>
+                                    </p:set>
+                                  </p:childTnLst>
+                                </p:cTn>
+                              </p:par>
+                            </p:childTnLst>
+                          </p:cTn>
+                        </p:par>
+                      </p:childTnLst>
+                    </p:cTn>
+                  </p:par>
+                  <p:par>
+                    <p:cTn id="11" fill="hold">
+                      <p:stCondLst>
+                        <p:cond delay="indefinite"/>
+                      </p:stCondLst>
+                      <p:childTnLst>
+                        <p:par>
+                          <p:cTn id="12" fill="hold">
+                            <p:stCondLst>
+                              <p:cond delay="0"/>
+                            </p:stCondLst>
+                            <p:childTnLst>
+                              <p:par>
+                                <p:cTn id="13" presetID="1" presetClass="entr" presetSubtype="0" fill="hold" nodeType="clickEffect">
+                                  <p:stCondLst>
+                                    <p:cond delay="0"/>
+                                  </p:stCondLst>
+                                  <p:childTnLst>
+                                    <p:set>
+                                      <p:cBhvr>
+                                        <p:cTn id="14" dur="1" fill="hold">
+                                          <p:stCondLst>
+                                            <p:cond delay="0"/>
+                                          </p:stCondLst>
+                                        </p:cTn>
+                                        <p:tgtEl>
+                                          <p:spTgt spid="3">
+                                            <p:txEl>
+                                              <p:pRg st="2" end="2"/>
+                                            </p:txEl>
+                                          </p:spTgt>
+                                        </p:tgtEl>
+                                        <p:attrNameLst>
+                                          <p:attrName>style.visibility</p:attrName>
+                                        </p:attrNameLst>
+                                      </p:cBhvr>
+                                      <p:to>
+                                        <p:strVal val="visible"/>
+                                      </p:to>
+                                    </p:set>
+                                  </p:childTnLst>
+                                </p:cTn>
+                              </p:par>
+                            </p:childTnLst>
+                          </p:cTn>
+                        </p:par>
+                      </p:childTnLst>
+                    </p:cTn>
+                  </p:par>
+                  <p:par>
+                    <p:cTn id="15" fill="hold">
+                      <p:stCondLst>
+                        <p:cond delay="indefinite"/>
+                      </p:stCondLst>
+                      <p:childTnLst>
+                        <p:par>
+                          <p:cTn id="16" fill="hold">
+                            <p:stCondLst>
+                              <p:cond delay="0"/>
+                            </p:stCondLst>
+                            <p:childTnLst>
+                              <p:par>
+                                <p:cTn id="17" presetID="1" presetClass="entr" presetSubtype="0" fill="hold" nodeType="clickEffect">
+                                  <p:stCondLst>
+                                    <p:cond delay="0"/>
+                                  </p:stCondLst>
+                                  <p:childTnLst>
+                                    <p:set>
+                                      <p:cBhvr>
+                                        <p:cTn id="18" dur="1" fill="hold">
+                                          <p:stCondLst>
+                                            <p:cond delay="0"/>
+                                          </p:stCondLst>
+                                        </p:cTn>
+                                        <p:tgtEl>
+                                          <p:spTgt spid="3">
+                                            <p:txEl>
+                                              <p:pRg st="3" end="3"/>
+                                            </p:txEl>
+                                          </p:spTgt>
+                                        </p:tgtEl>
+                                        <p:attrNameLst>
+                                          <p:attrName>style.visibility</p:attrName>
+                                        </p:attrNameLst>
+                                      </p:cBhvr>
+                                      <p:to>
+                                        <p:strVal val="visible"/>
+                                      </p:to>
+                                    </p:set>
+                                  </p:childTnLst>
+                                </p:cTn>
+                              </p:par>
+                            </p:childTnLst>
+                          </p:cTn>
+                        </p:par>
+                      </p:childTnLst>
+                    </p:cTn>
+                  </p:par>
+                  <p:par>
+                    <p:cTn id="19" fill="hold">
+                      <p:stCondLst>
+                        <p:cond delay="indefinite"/>
+                      </p:stCondLst>
+                      <p:childTnLst>
+                        <p:par>
+                          <p:cTn id="20" fill="hold">
+                            <p:stCondLst>
+                              <p:cond delay="0"/>
+                            </p:stCondLst>
+                            <p:childTnLst>
+                              <p:par>
+                                <p:cTn id="21" presetID="1" presetClass="entr" presetSubtype="0" fill="hold" grpId="0" nodeType="clickEffect">
+                                  <p:stCondLst>
+                                    <p:cond delay="0"/>
+                                  </p:stCondLst>
+                                  <p:childTnLst>
+                                    <p:set>
+                                      <p:cBhvr>
+                                        <p:cTn id="22" dur="1" fill="hold">
+                                          <p:stCondLst>
+                                            <p:cond delay="0"/>
+                                          </p:stCondLst>
+                                        </p:cTn>
+                                        <p:tgtEl>
+                                          <p:spTgt spid="6"/>
+                                        </p:tgtEl>
+                                        <p:attrNameLst>
+                                          <p:attrName>style.visibility</p:attrName>
+                                        </p:attrNameLst>
+                                      </p:cBhvr>
+                                      <p:to>
+                                        <p:strVal val="visible"/>
+                                      </p:to>
+                                    </p:set>
+                                  </p:childTnLst>
+                                </p:cTn>
+                              </p:par>
+                            </p:childTnLst>
+                          </p:cTn>
+                        </p:par>
+                      </p:childTnLst>
+                    </p:cTn>
+                  </p:par>
+                </p:childTnLst>
+              </p:cTn>
+              <p:prevCondLst>
+                <p:cond evt="onPrev" delay="0">
+                  <p:tgtEl>
+                    <p:sldTgt/>
+                  </p:tgtEl>
+                </p:cond>
+              </p:prevCondLst>
+              <p:nextCondLst>
+                <p:cond evt="onNext" delay="0">
+                  <p:tgtEl>
+                    <p:sldTgt/>
+                  </p:tgtEl>
+                </p:cond>
+              </p:nextCondLst>
+            </p:seq>
+          </p:childTnLst>
+        </p:cTn>
+      </p:par>
+    </p:tnLst>
+    <p:bldLst>
+      <p:bldP spid="6" grpId="0" animBg="1"/>
+    </p:bldLst>
+  </p:timing>
 </p:sld>
 </file>
 

</xml_diff>